<commit_message>
Update: add slide 2B NotebookLM + Magisterium
</commit_message>
<xml_diff>
--- a/ETB-IA-Religion-Video.pptx
+++ b/ETB-IA-Religion-Video.pptx
@@ -10,9 +10,10 @@
     <p:sldId id="258" r:id="rId4"/>
     <p:sldId id="259" r:id="rId5"/>
     <p:sldId id="260" r:id="rId6"/>
+    <p:sldId id="261" r:id="rId7"/>
   </p:sldIdLst>
   <p:notesMasterIdLst>
-    <p:notesMasterId r:id="rId7"/>
+    <p:notesMasterId r:id="rId8"/>
   </p:notesMasterIdLst>
   <p:sldSz cx="9144000" cy="5143500"/>
   <p:notesSz cx="5143500" cy="9144000"/>
@@ -697,15 +698,14 @@
           <a:p>
             <a:r>
               <a:rPr lang="en-US" dirty="0"/>
-              <a:t>NOTAS DEL PRESENTADOR — SLIDE 3 · EL PROMPT
-La sesión anterior les habló del prompt. Yo quiero profundizar en eso desde la perspectiva de ustedes — maestros de religión.
-Un prompt es simplemente el mensaje que le das a la IA. Pero la diferencia entre un prompt que da resultados genéricos y uno que da resultados útiles es una sola cosa: contexto.
-Miren el ejemplo de la izquierda. [señalar recuadro rojo] "Hazme un plan de clase sobre los sacramentos." La IA no sabe qué grado, no sabe qué objetivo, no sabe quiénes son tus estudiantes, no sabe qué dice la doctrina. Va a producir algo genérico.
-Ahora miren el de la derecha. [señalar recuadro verde] El mismo tema — los sacramentos — pero con grado, objetivo del estándar, referencia doctrinal, perfil del estudiante, y el tipo de experiencia que necesito. El output va a ser radicalmente diferente.
-La anatomía de un buen prompt tiene cinco partes: el rol que le asignas a la IA, el contexto de tu unidad, la tarea específica, el formato en que quieres el resultado, y las restricciones o límites.
-Y aquí está la clave — [pausa] — ese contexto no lo inventas. Lo construyes durante el workflow. NotebookLM y Magisterium te lo dan. Tú simplemente lo ensamblas.
-De hecho — al final del workflow — NotebookLM va a generar ese prompt por ti.
-[B-ROLL: pantalla mostrando prompt template en blanco vs. prompt completo]</a:t>
+              <a:t>NOTAS DEL PRESENTADOR — SLIDE 2B · HERRAMIENTAS DE EXPLORACIÓN
+Vamos a detenernos un momento en las dos herramientas del corazón del workflow, porque tienen propósitos muy distintos y se complementan de una manera que vale la pena entender.
+NotebookLM — de Google — es básicamente un asistente de lectura con esteroides. Tú le cargas documentos: el PDF de los estándares, tus notas, outputs de otras herramientas. Y luego conversas con él en lenguaje natural. No tienes que saber exactamente qué buscar — puedes preguntar como le preguntarías a un colega.
+[señalar bullets de NotebookLM]
+Lo que lo hace especialmente poderoso para nuestro workflow es que puedes convertir los outputs de la conversación en fuentes adicionales. Así el notebook va acumulando inteligencia — y al final te genera el brief y el prompt directamente desde ese contexto acumulado.
+Magisterium AI es diferente. Está diseñado exclusivamente para el Magisterio de la Iglesia Católica — Catecismo, Vaticano II, encíclicas, documentos sinodales. Sus fuentes están acotadas, lo que reduce el riesgo de que te invente citas. Pero igual — [señalar la barra roja] — siempre verifica en la fuente original antes de llevar algo al salón.
+El flujo entre las dos es simple: consultas en Magisterium, exportas a Google Docs, y desde Drive lo añades directamente a tu notebook en NotebookLM. Las dos herramientas se conectan sin fricciones.
+[B-ROLL: NotebookLM con fuentes cargadas · luego Magisterium en pantalla]</a:t>
             </a:r>
             <a:endParaRPr lang="en-US" dirty="0"/>
           </a:p>
@@ -793,13 +793,15 @@
           <a:p>
             <a:r>
               <a:rPr lang="en-US" dirty="0"/>
-              <a:t>NOTAS DEL PRESENTADOR — SLIDE 4 · COPILOTERE vs MAGICSCHOOL
-Una vez tienes el prompt listo — validado por ti — tienes dos opciones para ejecutarlo.
-CopilotERE es el asistente personalizado que hemos construido específicamente para maestros de religión. Tiene los estándares curriculares cargados. Recuerda el contexto de tu unidad durante toda la conversación. Es ideal cuando quieres iterar — generar un plan, ajustarlo, pedir una evaluación, refinar el hook — todo en una sola sesión.
-MagicSchool AI es una plataforma que ya muchos de ustedes conocen. Tiene herramientas específicas para cada tipo de recurso: Lesson Plan Generator, Hook Activity, Rubric Generator. Es ideal cuando sabes exactamente qué necesitas y quieres generarlo rápido.
-La buena noticia es que el mismo prompt que construiste funciona en los dos. No tienes que escribir dos prompts distintos. Solo eliges la herramienta según la ocasión.
-CopilotERE para conversación y contexto continuo. MagicSchool para un recurso específico y rápido.
-[B-ROLL: pantalla con CopilotERE abierto · mismo prompt ejecutado en MagicSchool]</a:t>
+              <a:t>NOTAS DEL PRESENTADOR — SLIDE 3 · EL PROMPT
+La sesión anterior les habló del prompt. Yo quiero profundizar en eso desde la perspectiva de ustedes — maestros de religión.
+Un prompt es simplemente el mensaje que le das a la IA. Pero la diferencia entre un prompt que da resultados genéricos y uno que da resultados útiles es una sola cosa: contexto.
+Miren el ejemplo de la izquierda. [señalar recuadro rojo] "Hazme un plan de clase sobre los sacramentos." La IA no sabe qué grado, no sabe qué objetivo, no sabe quiénes son tus estudiantes, no sabe qué dice la doctrina. Va a producir algo genérico.
+Ahora miren el de la derecha. [señalar recuadro verde] El mismo tema — los sacramentos — pero con grado, objetivo del estándar, referencia doctrinal, perfil del estudiante, y el tipo de experiencia que necesito. El output va a ser radicalmente diferente.
+La anatomía de un buen prompt tiene cinco partes: el rol que le asignas a la IA, el contexto de tu unidad, la tarea específica, el formato en que quieres el resultado, y las restricciones o límites.
+Y aquí está la clave — [pausa] — ese contexto no lo inventas. Lo construyes durante el workflow. NotebookLM y Magisterium te lo dan. Tú simplemente lo ensamblas.
+De hecho — al final del workflow — NotebookLM va a generar ese prompt por ti.
+[B-ROLL: pantalla mostrando prompt template en blanco vs. prompt completo]</a:t>
             </a:r>
             <a:endParaRPr lang="en-US" dirty="0"/>
           </a:p>
@@ -887,6 +889,100 @@
           <a:p>
             <a:r>
               <a:rPr lang="en-US" dirty="0"/>
+              <a:t>NOTAS DEL PRESENTADOR — SLIDE 4 · COPILOTERE vs MAGICSCHOOL
+Una vez tienes el prompt listo — validado por ti — tienes dos opciones para ejecutarlo.
+CopilotERE es el asistente personalizado que hemos construido específicamente para maestros de religión. Tiene los estándares curriculares cargados. Recuerda el contexto de tu unidad durante toda la conversación. Es ideal cuando quieres iterar — generar un plan, ajustarlo, pedir una evaluación, refinar el hook — todo en una sola sesión.
+MagicSchool AI es una plataforma que ya muchos de ustedes conocen. Tiene herramientas específicas para cada tipo de recurso: Lesson Plan Generator, Hook Activity, Rubric Generator. Es ideal cuando sabes exactamente qué necesitas y quieres generarlo rápido.
+La buena noticia es que el mismo prompt que construiste funciona en los dos. No tienes que escribir dos prompts distintos. Solo eliges la herramienta según la ocasión.
+CopilotERE para conversación y contexto continuo. MagicSchool para un recurso específico y rápido.
+[B-ROLL: pantalla con CopilotERE abierto · mismo prompt ejecutado en MagicSchool]</a:t>
+            </a:r>
+            <a:endParaRPr lang="en-US" dirty="0"/>
+          </a:p>
+        </p:txBody>
+      </p:sp>
+      <p:sp>
+        <p:nvSpPr>
+          <p:cNvPr id="4" name="Slide Number Placeholder 3"/>
+          <p:cNvSpPr>
+            <a:spLocks noGrp="1"/>
+          </p:cNvSpPr>
+          <p:nvPr>
+            <p:ph type="sldNum" sz="quarter" idx="10"/>
+          </p:nvPr>
+        </p:nvSpPr>
+        <p:spPr/>
+        <p:txBody>
+          <a:bodyPr/>
+          <a:lstStyle/>
+          <a:p>
+            <a:fld id="{F7021451-1387-4CA6-816F-3879F97B5CBC}" type="slidenum">
+              <a:rPr lang="en-US"/>
+              <a:t>5</a:t>
+            </a:fld>
+            <a:endParaRPr lang="en-US"/>
+          </a:p>
+        </p:txBody>
+      </p:sp>
+    </p:spTree>
+    <p:extLst>
+      <p:ext uri="{BB962C8B-B14F-4D97-AF65-F5344CB8AC3E}">
+        <p14:creationId xmlns:p14="http://schemas.microsoft.com/office/powerpoint/2010/main" val="1024086991"/>
+      </p:ext>
+    </p:extLst>
+  </p:cSld>
+  <p:clrMapOvr>
+    <a:masterClrMapping/>
+  </p:clrMapOvr>
+</p:notes>
+</file>
+
+<file path=ppt/notesSlides/notesSlide6.xml><?xml version="1.0" encoding="utf-8"?>
+<p:notes xmlns:a="http://schemas.openxmlformats.org/drawingml/2006/main" xmlns:r="http://schemas.openxmlformats.org/officeDocument/2006/relationships" xmlns:p="http://schemas.openxmlformats.org/presentationml/2006/main">
+  <p:cSld>
+    <p:spTree>
+      <p:nvGrpSpPr>
+        <p:cNvPr id="1" name=""/>
+        <p:cNvGrpSpPr/>
+        <p:nvPr/>
+      </p:nvGrpSpPr>
+      <p:grpSpPr>
+        <a:xfrm>
+          <a:off x="0" y="0"/>
+          <a:ext cx="0" cy="0"/>
+          <a:chOff x="0" y="0"/>
+          <a:chExt cx="0" cy="0"/>
+        </a:xfrm>
+      </p:grpSpPr>
+      <p:sp>
+        <p:nvSpPr>
+          <p:cNvPr id="2" name="Slide Image Placeholder 1"/>
+          <p:cNvSpPr>
+            <a:spLocks noGrp="1" noRot="1" noChangeAspect="1"/>
+          </p:cNvSpPr>
+          <p:nvPr>
+            <p:ph type="sldImg"/>
+          </p:nvPr>
+        </p:nvSpPr>
+        <p:spPr/>
+      </p:sp>
+      <p:sp>
+        <p:nvSpPr>
+          <p:cNvPr id="3" name="Notes Placeholder 2"/>
+          <p:cNvSpPr>
+            <a:spLocks noGrp="1"/>
+          </p:cNvSpPr>
+          <p:nvPr>
+            <p:ph type="body" idx="1"/>
+          </p:nvPr>
+        </p:nvSpPr>
+        <p:spPr/>
+        <p:txBody>
+          <a:bodyPr/>
+          <a:lstStyle/>
+          <a:p>
+            <a:r>
+              <a:rPr lang="en-US" dirty="0"/>
               <a:t>NOTAS DEL PRESENTADOR — SLIDE 5 · CIERRE
 Resumamos en 60 segundos lo que vimos hoy.
 El workflow empieza en el libro — el recurso que ya tienen en mano. Desde ahí generamos el primer prompt para NotebookLM, donde conversamos con el documento de estándares. Luego vamos a Magisterium para validar las fuentes doctrinales, y esos outputs los añadimos al notebook. Con todo cargado, le pedimos el brief — y con solo el brief activo, NotebookLM nos genera el prompt listo para CopilotERE o MagicSchool. Y el resultado es una experiencia de aprendizaje fundamentada en el estándar, anclada en la doctrina, y diseñada para tus estudiantes reales.
@@ -919,7 +1015,7 @@
           <a:p>
             <a:fld id="{F7021451-1387-4CA6-816F-3879F97B5CBC}" type="slidenum">
               <a:rPr lang="en-US"/>
-              <a:t>5</a:t>
+              <a:t>6</a:t>
             </a:fld>
             <a:endParaRPr lang="en-US"/>
           </a:p>
@@ -3427,7 +3523,7 @@
                 <a:ea typeface="Calibri" pitchFamily="34" charset="-122"/>
                 <a:cs typeface="Calibri" pitchFamily="34" charset="-120"/>
               </a:rPr>
-              <a:t>FUNDAMENTO · EL PROMPT</a:t>
+              <a:t>HERRAMIENTAS DE EXPLORACIÓN Y VALIDACIÓN</a:t>
             </a:r>
             <a:endParaRPr lang="en-US" sz="850" dirty="0"/>
           </a:p>
@@ -3442,7 +3538,7 @@
         <p:spPr>
           <a:xfrm>
             <a:off x="457200" y="457200"/>
-            <a:ext cx="8229600" cy="502920"/>
+            <a:ext cx="8229600" cy="411480"/>
           </a:xfrm>
           <a:prstGeom prst="rect">
             <a:avLst/>
@@ -3458,7 +3554,7 @@
               <a:buNone/>
             </a:pPr>
             <a:r>
-              <a:rPr lang="en-US" sz="2600" b="1" dirty="0">
+              <a:rPr lang="en-US" sz="1900" b="1" dirty="0">
                 <a:solidFill>
                   <a:srgbClr val="333333"/>
                 </a:solidFill>
@@ -3466,9 +3562,9 @@
                 <a:ea typeface="Trebuchet MS" pitchFamily="34" charset="-122"/>
                 <a:cs typeface="Trebuchet MS" pitchFamily="34" charset="-120"/>
               </a:rPr>
-              <a:t>El prompt no es magia — es contexto</a:t>
-            </a:r>
-            <a:endParaRPr lang="en-US" sz="2600" dirty="0"/>
+              <a:t>NotebookLM y Magisterium: distintos, complementarios.</a:t>
+            </a:r>
+            <a:endParaRPr lang="en-US" sz="1900" dirty="0"/>
           </a:p>
         </p:txBody>
       </p:sp>
@@ -3480,18 +3576,48 @@
         </p:nvSpPr>
         <p:spPr>
           <a:xfrm>
-            <a:off x="457200" y="1115568"/>
-            <a:ext cx="1280160" cy="347472"/>
-          </a:xfrm>
-          <a:prstGeom prst="rect">
-            <a:avLst/>
-          </a:prstGeom>
-          <a:solidFill>
-            <a:srgbClr val="00B4D8">
-              <a:alpha val="12000"/>
-            </a:srgbClr>
-          </a:solidFill>
-          <a:ln w="10160">
+            <a:off x="457200" y="1005840"/>
+            <a:ext cx="3840480" cy="3429000"/>
+          </a:xfrm>
+          <a:prstGeom prst="rect">
+            <a:avLst/>
+          </a:prstGeom>
+          <a:solidFill>
+            <a:srgbClr val="F0FBFF"/>
+          </a:solidFill>
+          <a:ln w="12700">
+            <a:solidFill>
+              <a:srgbClr val="CAF0F8"/>
+            </a:solidFill>
+            <a:prstDash val="solid"/>
+          </a:ln>
+          <a:effectLst>
+            <a:outerShdw sx="100000" sy="100000" kx="0" ky="0" algn="bl" rotWithShape="0" blurRad="101600" dist="38100" dir="8100000">
+              <a:srgbClr val="000000">
+                <a:alpha val="12000"/>
+              </a:srgbClr>
+            </a:outerShdw>
+          </a:effectLst>
+        </p:spPr>
+      </p:sp>
+      <p:sp>
+        <p:nvSpPr>
+          <p:cNvPr id="6" name="Shape 4"/>
+          <p:cNvSpPr/>
+          <p:nvPr/>
+        </p:nvSpPr>
+        <p:spPr>
+          <a:xfrm>
+            <a:off x="457200" y="1005840"/>
+            <a:ext cx="3840480" cy="54864"/>
+          </a:xfrm>
+          <a:prstGeom prst="rect">
+            <a:avLst/>
+          </a:prstGeom>
+          <a:solidFill>
+            <a:srgbClr val="00B4D8"/>
+          </a:solidFill>
+          <a:ln w="12700">
             <a:solidFill>
               <a:srgbClr val="00B4D8"/>
             </a:solidFill>
@@ -3501,53 +3627,14 @@
       </p:sp>
       <p:sp>
         <p:nvSpPr>
-          <p:cNvPr id="6" name="Text 4"/>
-          <p:cNvSpPr/>
-          <p:nvPr/>
-        </p:nvSpPr>
-        <p:spPr>
-          <a:xfrm>
-            <a:off x="457200" y="1115568"/>
-            <a:ext cx="1280160" cy="347472"/>
-          </a:xfrm>
-          <a:prstGeom prst="rect">
-            <a:avLst/>
-          </a:prstGeom>
-          <a:noFill/>
-          <a:ln/>
-        </p:spPr>
-        <p:txBody>
-          <a:bodyPr wrap="square" lIns="0" tIns="0" rIns="0" bIns="0" rtlCol="0" anchor="ctr"/>
-          <a:lstStyle/>
-          <a:p>
-            <a:pPr algn="ctr" indent="0" marL="0">
-              <a:buNone/>
-            </a:pPr>
-            <a:r>
-              <a:rPr lang="en-US" sz="850" b="1" dirty="0">
-                <a:solidFill>
-                  <a:srgbClr val="00B4D8"/>
-                </a:solidFill>
-                <a:latin typeface="Calibri" pitchFamily="34" charset="0"/>
-                <a:ea typeface="Calibri" pitchFamily="34" charset="-122"/>
-                <a:cs typeface="Calibri" pitchFamily="34" charset="-120"/>
-              </a:rPr>
-              <a:t>ROL</a:t>
-            </a:r>
-            <a:endParaRPr lang="en-US" sz="850" dirty="0"/>
-          </a:p>
-        </p:txBody>
-      </p:sp>
-      <p:sp>
-        <p:nvSpPr>
           <p:cNvPr id="7" name="Text 5"/>
           <p:cNvSpPr/>
           <p:nvPr/>
         </p:nvSpPr>
         <p:spPr>
           <a:xfrm>
-            <a:off x="1874520" y="1152144"/>
-            <a:ext cx="3749040" cy="274320"/>
+            <a:off x="594360" y="1078992"/>
+            <a:ext cx="3566160" cy="438912"/>
           </a:xfrm>
           <a:prstGeom prst="rect">
             <a:avLst/>
@@ -3563,7 +3650,89 @@
               <a:buNone/>
             </a:pPr>
             <a:r>
-              <a:rPr lang="en-US" sz="1050" dirty="0">
+              <a:rPr lang="en-US" sz="1700" b="1" dirty="0">
+                <a:solidFill>
+                  <a:srgbClr val="0096B7"/>
+                </a:solidFill>
+                <a:latin typeface="Trebuchet MS" pitchFamily="34" charset="0"/>
+                <a:ea typeface="Trebuchet MS" pitchFamily="34" charset="-122"/>
+                <a:cs typeface="Trebuchet MS" pitchFamily="34" charset="-120"/>
+              </a:rPr>
+              <a:t>🗂️  NotebookLM</a:t>
+            </a:r>
+            <a:endParaRPr lang="en-US" sz="1700" dirty="0"/>
+          </a:p>
+        </p:txBody>
+      </p:sp>
+      <p:sp>
+        <p:nvSpPr>
+          <p:cNvPr id="8" name="Text 6"/>
+          <p:cNvSpPr/>
+          <p:nvPr/>
+        </p:nvSpPr>
+        <p:spPr>
+          <a:xfrm>
+            <a:off x="594360" y="1508760"/>
+            <a:ext cx="3566160" cy="256032"/>
+          </a:xfrm>
+          <a:prstGeom prst="rect">
+            <a:avLst/>
+          </a:prstGeom>
+          <a:noFill/>
+          <a:ln/>
+        </p:spPr>
+        <p:txBody>
+          <a:bodyPr wrap="square" lIns="0" tIns="0" rIns="0" bIns="0" rtlCol="0" anchor="ctr"/>
+          <a:lstStyle/>
+          <a:p>
+            <a:pPr indent="0" marL="0">
+              <a:buNone/>
+            </a:pPr>
+            <a:r>
+              <a:rPr lang="en-US" sz="950" i="1" dirty="0">
+                <a:solidFill>
+                  <a:srgbClr val="666666"/>
+                </a:solidFill>
+                <a:latin typeface="Calibri" pitchFamily="34" charset="0"/>
+                <a:ea typeface="Calibri" pitchFamily="34" charset="-122"/>
+                <a:cs typeface="Calibri" pitchFamily="34" charset="-120"/>
+              </a:rPr>
+              <a:t>Conversar con los estándares curriculares</a:t>
+            </a:r>
+            <a:endParaRPr lang="en-US" sz="950" dirty="0"/>
+          </a:p>
+        </p:txBody>
+      </p:sp>
+      <p:sp>
+        <p:nvSpPr>
+          <p:cNvPr id="9" name="Text 7"/>
+          <p:cNvSpPr/>
+          <p:nvPr/>
+        </p:nvSpPr>
+        <p:spPr>
+          <a:xfrm>
+            <a:off x="594360" y="1828800"/>
+            <a:ext cx="3566160" cy="2468880"/>
+          </a:xfrm>
+          <a:prstGeom prst="rect">
+            <a:avLst/>
+          </a:prstGeom>
+          <a:noFill/>
+          <a:ln/>
+        </p:spPr>
+        <p:txBody>
+          <a:bodyPr wrap="square" rtlCol="0" anchor="ctr"/>
+          <a:lstStyle/>
+          <a:p>
+            <a:pPr marL="342900" indent="-342900">
+              <a:spcAft>
+                <a:spcPts val="300"/>
+              </a:spcAft>
+              <a:buSzPct val="100000"/>
+              <a:buChar char="•"/>
+            </a:pPr>
+            <a:r>
+              <a:rPr lang="en-US" sz="1000" dirty="0">
                 <a:solidFill>
                   <a:srgbClr val="333333"/>
                 </a:solidFill>
@@ -3571,116 +3740,148 @@
                 <a:ea typeface="Calibri" pitchFamily="34" charset="-122"/>
                 <a:cs typeface="Calibri" pitchFamily="34" charset="-120"/>
               </a:rPr>
-              <a:t>¿Quién es la IA en esta conversación?</a:t>
-            </a:r>
-            <a:endParaRPr lang="en-US" sz="1050" dirty="0"/>
-          </a:p>
-        </p:txBody>
-      </p:sp>
-      <p:sp>
-        <p:nvSpPr>
-          <p:cNvPr id="8" name="Shape 6"/>
-          <p:cNvSpPr/>
-          <p:nvPr/>
-        </p:nvSpPr>
-        <p:spPr>
-          <a:xfrm>
-            <a:off x="457200" y="1783080"/>
-            <a:ext cx="1280160" cy="347472"/>
-          </a:xfrm>
-          <a:prstGeom prst="rect">
-            <a:avLst/>
-          </a:prstGeom>
-          <a:solidFill>
-            <a:srgbClr val="0096B7">
-              <a:alpha val="12000"/>
-            </a:srgbClr>
-          </a:solidFill>
-          <a:ln w="10160">
+              <a:t>Carga el PDF de estándares como fuente</a:t>
+            </a:r>
+            <a:endParaRPr lang="en-US" sz="1000" dirty="0"/>
+          </a:p>
+          <a:p>
+            <a:pPr marL="342900" indent="-342900">
+              <a:spcAft>
+                <a:spcPts val="300"/>
+              </a:spcAft>
+              <a:buSzPct val="100000"/>
+              <a:buChar char="•"/>
+            </a:pPr>
+            <a:r>
+              <a:rPr lang="en-US" sz="1000" dirty="0">
+                <a:solidFill>
+                  <a:srgbClr val="333333"/>
+                </a:solidFill>
+                <a:latin typeface="Calibri" pitchFamily="34" charset="0"/>
+                <a:ea typeface="Calibri" pitchFamily="34" charset="-122"/>
+                <a:cs typeface="Calibri" pitchFamily="34" charset="-120"/>
+              </a:rPr>
+              <a:t>Pregunta en lenguaje natural, sin tecnicismos</a:t>
+            </a:r>
+            <a:endParaRPr lang="en-US" sz="1000" dirty="0"/>
+          </a:p>
+          <a:p>
+            <a:pPr marL="342900" indent="-342900">
+              <a:spcAft>
+                <a:spcPts val="300"/>
+              </a:spcAft>
+              <a:buSzPct val="100000"/>
+              <a:buChar char="•"/>
+            </a:pPr>
+            <a:r>
+              <a:rPr lang="en-US" sz="1000" dirty="0">
+                <a:solidFill>
+                  <a:srgbClr val="333333"/>
+                </a:solidFill>
+                <a:latin typeface="Calibri" pitchFamily="34" charset="0"/>
+                <a:ea typeface="Calibri" pitchFamily="34" charset="-122"/>
+                <a:cs typeface="Calibri" pitchFamily="34" charset="-120"/>
+              </a:rPr>
+              <a:t>Convierte los outputs en Notes → Sources</a:t>
+            </a:r>
+            <a:endParaRPr lang="en-US" sz="1000" dirty="0"/>
+          </a:p>
+          <a:p>
+            <a:pPr marL="342900" indent="-342900">
+              <a:spcAft>
+                <a:spcPts val="300"/>
+              </a:spcAft>
+              <a:buSzPct val="100000"/>
+              <a:buChar char="•"/>
+            </a:pPr>
+            <a:r>
+              <a:rPr lang="en-US" sz="1000" dirty="0">
+                <a:solidFill>
+                  <a:srgbClr val="333333"/>
+                </a:solidFill>
+                <a:latin typeface="Calibri" pitchFamily="34" charset="0"/>
+                <a:ea typeface="Calibri" pitchFamily="34" charset="-122"/>
+                <a:cs typeface="Calibri" pitchFamily="34" charset="-120"/>
+              </a:rPr>
+              <a:t>Añade fuentes de Magisterium via Google Drive</a:t>
+            </a:r>
+            <a:endParaRPr lang="en-US" sz="1000" dirty="0"/>
+          </a:p>
+          <a:p>
+            <a:pPr marL="342900" indent="-342900">
+              <a:spcAft>
+                <a:spcPts val="300"/>
+              </a:spcAft>
+              <a:buSzPct val="100000"/>
+              <a:buChar char="•"/>
+            </a:pPr>
+            <a:r>
+              <a:rPr lang="en-US" sz="1000" dirty="0">
+                <a:solidFill>
+                  <a:srgbClr val="333333"/>
+                </a:solidFill>
+                <a:latin typeface="Calibri" pitchFamily="34" charset="0"/>
+                <a:ea typeface="Calibri" pitchFamily="34" charset="-122"/>
+                <a:cs typeface="Calibri" pitchFamily="34" charset="-120"/>
+              </a:rPr>
+              <a:t>Genera el brief con todas las fuentes activas</a:t>
+            </a:r>
+            <a:endParaRPr lang="en-US" sz="1000" dirty="0"/>
+          </a:p>
+          <a:p>
+            <a:pPr marL="342900" indent="-342900">
+              <a:spcAft>
+                <a:spcPts val="300"/>
+              </a:spcAft>
+              <a:buSzPct val="100000"/>
+              <a:buChar char="•"/>
+            </a:pPr>
+            <a:r>
+              <a:rPr lang="en-US" sz="1000" dirty="0">
+                <a:solidFill>
+                  <a:srgbClr val="333333"/>
+                </a:solidFill>
+                <a:latin typeface="Calibri" pitchFamily="34" charset="0"/>
+                <a:ea typeface="Calibri" pitchFamily="34" charset="-122"/>
+                <a:cs typeface="Calibri" pitchFamily="34" charset="-120"/>
+              </a:rPr>
+              <a:t>Con solo el brief: genera el prompt final</a:t>
+            </a:r>
+            <a:endParaRPr lang="en-US" sz="1000" dirty="0"/>
+          </a:p>
+        </p:txBody>
+      </p:sp>
+      <p:sp>
+        <p:nvSpPr>
+          <p:cNvPr id="10" name="Shape 8"/>
+          <p:cNvSpPr/>
+          <p:nvPr/>
+        </p:nvSpPr>
+        <p:spPr>
+          <a:xfrm>
+            <a:off x="4846320" y="1005840"/>
+            <a:ext cx="3840480" cy="3429000"/>
+          </a:xfrm>
+          <a:prstGeom prst="rect">
+            <a:avLst/>
+          </a:prstGeom>
+          <a:solidFill>
+            <a:srgbClr val="F0FFF4"/>
+          </a:solidFill>
+          <a:ln w="12700">
             <a:solidFill>
-              <a:srgbClr val="0096B7"/>
+              <a:srgbClr val="333333"/>
             </a:solidFill>
             <a:prstDash val="solid"/>
           </a:ln>
-        </p:spPr>
-      </p:sp>
-      <p:sp>
-        <p:nvSpPr>
-          <p:cNvPr id="9" name="Text 7"/>
-          <p:cNvSpPr/>
-          <p:nvPr/>
-        </p:nvSpPr>
-        <p:spPr>
-          <a:xfrm>
-            <a:off x="457200" y="1783080"/>
-            <a:ext cx="1280160" cy="347472"/>
-          </a:xfrm>
-          <a:prstGeom prst="rect">
-            <a:avLst/>
-          </a:prstGeom>
-          <a:noFill/>
-          <a:ln/>
-        </p:spPr>
-        <p:txBody>
-          <a:bodyPr wrap="square" lIns="0" tIns="0" rIns="0" bIns="0" rtlCol="0" anchor="ctr"/>
-          <a:lstStyle/>
-          <a:p>
-            <a:pPr algn="ctr" indent="0" marL="0">
-              <a:buNone/>
-            </a:pPr>
-            <a:r>
-              <a:rPr lang="en-US" sz="850" b="1" dirty="0">
-                <a:solidFill>
-                  <a:srgbClr val="0096B7"/>
-                </a:solidFill>
-                <a:latin typeface="Calibri" pitchFamily="34" charset="0"/>
-                <a:ea typeface="Calibri" pitchFamily="34" charset="-122"/>
-                <a:cs typeface="Calibri" pitchFamily="34" charset="-120"/>
-              </a:rPr>
-              <a:t>CONTEXTO</a:t>
-            </a:r>
-            <a:endParaRPr lang="en-US" sz="850" dirty="0"/>
-          </a:p>
-        </p:txBody>
-      </p:sp>
-      <p:sp>
-        <p:nvSpPr>
-          <p:cNvPr id="10" name="Text 8"/>
-          <p:cNvSpPr/>
-          <p:nvPr/>
-        </p:nvSpPr>
-        <p:spPr>
-          <a:xfrm>
-            <a:off x="1874520" y="1819656"/>
-            <a:ext cx="3749040" cy="274320"/>
-          </a:xfrm>
-          <a:prstGeom prst="rect">
-            <a:avLst/>
-          </a:prstGeom>
-          <a:noFill/>
-          <a:ln/>
-        </p:spPr>
-        <p:txBody>
-          <a:bodyPr wrap="square" lIns="0" tIns="0" rIns="0" bIns="0" rtlCol="0" anchor="ctr"/>
-          <a:lstStyle/>
-          <a:p>
-            <a:pPr indent="0" marL="0">
-              <a:buNone/>
-            </a:pPr>
-            <a:r>
-              <a:rPr lang="en-US" sz="1050" dirty="0">
-                <a:solidFill>
-                  <a:srgbClr val="333333"/>
-                </a:solidFill>
-                <a:latin typeface="Calibri" pitchFamily="34" charset="0"/>
-                <a:ea typeface="Calibri" pitchFamily="34" charset="-122"/>
-                <a:cs typeface="Calibri" pitchFamily="34" charset="-120"/>
-              </a:rPr>
-              <a:t>Grado · Tema · Estándar · Doctrina · Perfil del estudiante</a:t>
-            </a:r>
-            <a:endParaRPr lang="en-US" sz="1050" dirty="0"/>
-          </a:p>
-        </p:txBody>
+          <a:effectLst>
+            <a:outerShdw sx="100000" sy="100000" kx="0" ky="0" algn="bl" rotWithShape="0" blurRad="101600" dist="38100" dir="8100000">
+              <a:srgbClr val="000000">
+                <a:alpha val="12000"/>
+              </a:srgbClr>
+            </a:outerShdw>
+          </a:effectLst>
+        </p:spPr>
       </p:sp>
       <p:sp>
         <p:nvSpPr>
@@ -3690,18 +3891,16 @@
         </p:nvSpPr>
         <p:spPr>
           <a:xfrm>
-            <a:off x="457200" y="2450592"/>
-            <a:ext cx="1280160" cy="347472"/>
-          </a:xfrm>
-          <a:prstGeom prst="rect">
-            <a:avLst/>
-          </a:prstGeom>
-          <a:solidFill>
-            <a:srgbClr val="2DC653">
-              <a:alpha val="12000"/>
-            </a:srgbClr>
-          </a:solidFill>
-          <a:ln w="10160">
+            <a:off x="4846320" y="1005840"/>
+            <a:ext cx="3840480" cy="54864"/>
+          </a:xfrm>
+          <a:prstGeom prst="rect">
+            <a:avLst/>
+          </a:prstGeom>
+          <a:solidFill>
+            <a:srgbClr val="2DC653"/>
+          </a:solidFill>
+          <a:ln w="12700">
             <a:solidFill>
               <a:srgbClr val="2DC653"/>
             </a:solidFill>
@@ -3717,34 +3916,34 @@
         </p:nvSpPr>
         <p:spPr>
           <a:xfrm>
-            <a:off x="457200" y="2450592"/>
-            <a:ext cx="1280160" cy="347472"/>
-          </a:xfrm>
-          <a:prstGeom prst="rect">
-            <a:avLst/>
-          </a:prstGeom>
-          <a:noFill/>
-          <a:ln/>
-        </p:spPr>
-        <p:txBody>
-          <a:bodyPr wrap="square" lIns="0" tIns="0" rIns="0" bIns="0" rtlCol="0" anchor="ctr"/>
-          <a:lstStyle/>
-          <a:p>
-            <a:pPr algn="ctr" indent="0" marL="0">
-              <a:buNone/>
-            </a:pPr>
-            <a:r>
-              <a:rPr lang="en-US" sz="850" b="1" dirty="0">
+            <a:off x="4983480" y="1078992"/>
+            <a:ext cx="3566160" cy="438912"/>
+          </a:xfrm>
+          <a:prstGeom prst="rect">
+            <a:avLst/>
+          </a:prstGeom>
+          <a:noFill/>
+          <a:ln/>
+        </p:spPr>
+        <p:txBody>
+          <a:bodyPr wrap="square" lIns="0" tIns="0" rIns="0" bIns="0" rtlCol="0" anchor="ctr"/>
+          <a:lstStyle/>
+          <a:p>
+            <a:pPr indent="0" marL="0">
+              <a:buNone/>
+            </a:pPr>
+            <a:r>
+              <a:rPr lang="en-US" sz="1700" b="1" dirty="0">
                 <a:solidFill>
                   <a:srgbClr val="2DC653"/>
                 </a:solidFill>
-                <a:latin typeface="Calibri" pitchFamily="34" charset="0"/>
-                <a:ea typeface="Calibri" pitchFamily="34" charset="-122"/>
-                <a:cs typeface="Calibri" pitchFamily="34" charset="-120"/>
-              </a:rPr>
-              <a:t>TAREA</a:t>
-            </a:r>
-            <a:endParaRPr lang="en-US" sz="850" dirty="0"/>
+                <a:latin typeface="Trebuchet MS" pitchFamily="34" charset="0"/>
+                <a:ea typeface="Trebuchet MS" pitchFamily="34" charset="-122"/>
+                <a:cs typeface="Trebuchet MS" pitchFamily="34" charset="-120"/>
+              </a:rPr>
+              <a:t>✝️  Magisterium AI</a:t>
+            </a:r>
+            <a:endParaRPr lang="en-US" sz="1700" dirty="0"/>
           </a:p>
         </p:txBody>
       </p:sp>
@@ -3756,8 +3955,8 @@
         </p:nvSpPr>
         <p:spPr>
           <a:xfrm>
-            <a:off x="1874520" y="2487168"/>
-            <a:ext cx="3749040" cy="274320"/>
+            <a:off x="4983480" y="1508760"/>
+            <a:ext cx="3566160" cy="256032"/>
           </a:xfrm>
           <a:prstGeom prst="rect">
             <a:avLst/>
@@ -3773,7 +3972,50 @@
               <a:buNone/>
             </a:pPr>
             <a:r>
-              <a:rPr lang="en-US" sz="1050" dirty="0">
+              <a:rPr lang="en-US" sz="950" i="1" dirty="0">
+                <a:solidFill>
+                  <a:srgbClr val="666666"/>
+                </a:solidFill>
+                <a:latin typeface="Calibri" pitchFamily="34" charset="0"/>
+                <a:ea typeface="Calibri" pitchFamily="34" charset="-122"/>
+                <a:cs typeface="Calibri" pitchFamily="34" charset="-120"/>
+              </a:rPr>
+              <a:t>Validar fuentes doctrinales del Magisterio</a:t>
+            </a:r>
+            <a:endParaRPr lang="en-US" sz="950" dirty="0"/>
+          </a:p>
+        </p:txBody>
+      </p:sp>
+      <p:sp>
+        <p:nvSpPr>
+          <p:cNvPr id="14" name="Text 12"/>
+          <p:cNvSpPr/>
+          <p:nvPr/>
+        </p:nvSpPr>
+        <p:spPr>
+          <a:xfrm>
+            <a:off x="4983480" y="1828800"/>
+            <a:ext cx="3566160" cy="2468880"/>
+          </a:xfrm>
+          <a:prstGeom prst="rect">
+            <a:avLst/>
+          </a:prstGeom>
+          <a:noFill/>
+          <a:ln/>
+        </p:spPr>
+        <p:txBody>
+          <a:bodyPr wrap="square" rtlCol="0" anchor="ctr"/>
+          <a:lstStyle/>
+          <a:p>
+            <a:pPr marL="342900" indent="-342900">
+              <a:spcAft>
+                <a:spcPts val="300"/>
+              </a:spcAft>
+              <a:buSzPct val="100000"/>
+              <a:buChar char="•"/>
+            </a:pPr>
+            <a:r>
+              <a:rPr lang="en-US" sz="1000" dirty="0">
                 <a:solidFill>
                   <a:srgbClr val="333333"/>
                 </a:solidFill>
@@ -3781,104 +4023,20 @@
                 <a:ea typeface="Calibri" pitchFamily="34" charset="-122"/>
                 <a:cs typeface="Calibri" pitchFamily="34" charset="-120"/>
               </a:rPr>
-              <a:t>¿Qué quieres que genere exactamente?</a:t>
-            </a:r>
-            <a:endParaRPr lang="en-US" sz="1050" dirty="0"/>
-          </a:p>
-        </p:txBody>
-      </p:sp>
-      <p:sp>
-        <p:nvSpPr>
-          <p:cNvPr id="14" name="Shape 12"/>
-          <p:cNvSpPr/>
-          <p:nvPr/>
-        </p:nvSpPr>
-        <p:spPr>
-          <a:xfrm>
-            <a:off x="457200" y="3118104"/>
-            <a:ext cx="1280160" cy="347472"/>
-          </a:xfrm>
-          <a:prstGeom prst="rect">
-            <a:avLst/>
-          </a:prstGeom>
-          <a:solidFill>
-            <a:srgbClr val="7B5EA7">
-              <a:alpha val="12000"/>
-            </a:srgbClr>
-          </a:solidFill>
-          <a:ln w="10160">
-            <a:solidFill>
-              <a:srgbClr val="7B5EA7"/>
-            </a:solidFill>
-            <a:prstDash val="solid"/>
-          </a:ln>
-        </p:spPr>
-      </p:sp>
-      <p:sp>
-        <p:nvSpPr>
-          <p:cNvPr id="15" name="Text 13"/>
-          <p:cNvSpPr/>
-          <p:nvPr/>
-        </p:nvSpPr>
-        <p:spPr>
-          <a:xfrm>
-            <a:off x="457200" y="3118104"/>
-            <a:ext cx="1280160" cy="347472"/>
-          </a:xfrm>
-          <a:prstGeom prst="rect">
-            <a:avLst/>
-          </a:prstGeom>
-          <a:noFill/>
-          <a:ln/>
-        </p:spPr>
-        <p:txBody>
-          <a:bodyPr wrap="square" lIns="0" tIns="0" rIns="0" bIns="0" rtlCol="0" anchor="ctr"/>
-          <a:lstStyle/>
-          <a:p>
-            <a:pPr algn="ctr" indent="0" marL="0">
-              <a:buNone/>
-            </a:pPr>
-            <a:r>
-              <a:rPr lang="en-US" sz="850" b="1" dirty="0">
-                <a:solidFill>
-                  <a:srgbClr val="7B5EA7"/>
-                </a:solidFill>
-                <a:latin typeface="Calibri" pitchFamily="34" charset="0"/>
-                <a:ea typeface="Calibri" pitchFamily="34" charset="-122"/>
-                <a:cs typeface="Calibri" pitchFamily="34" charset="-120"/>
-              </a:rPr>
-              <a:t>FORMATO</a:t>
-            </a:r>
-            <a:endParaRPr lang="en-US" sz="850" dirty="0"/>
-          </a:p>
-        </p:txBody>
-      </p:sp>
-      <p:sp>
-        <p:nvSpPr>
-          <p:cNvPr id="16" name="Text 14"/>
-          <p:cNvSpPr/>
-          <p:nvPr/>
-        </p:nvSpPr>
-        <p:spPr>
-          <a:xfrm>
-            <a:off x="1874520" y="3154680"/>
-            <a:ext cx="3749040" cy="274320"/>
-          </a:xfrm>
-          <a:prstGeom prst="rect">
-            <a:avLst/>
-          </a:prstGeom>
-          <a:noFill/>
-          <a:ln/>
-        </p:spPr>
-        <p:txBody>
-          <a:bodyPr wrap="square" lIns="0" tIns="0" rIns="0" bIns="0" rtlCol="0" anchor="ctr"/>
-          <a:lstStyle/>
-          <a:p>
-            <a:pPr indent="0" marL="0">
-              <a:buNone/>
-            </a:pPr>
-            <a:r>
-              <a:rPr lang="en-US" sz="1050" dirty="0">
+              <a:t>Fuentes acotadas al Magisterio oficial (CIC, Vaticano II, encíclicas)</a:t>
+            </a:r>
+            <a:endParaRPr lang="en-US" sz="1000" dirty="0"/>
+          </a:p>
+          <a:p>
+            <a:pPr marL="342900" indent="-342900">
+              <a:spcAft>
+                <a:spcPts val="300"/>
+              </a:spcAft>
+              <a:buSzPct val="100000"/>
+              <a:buChar char="•"/>
+            </a:pPr>
+            <a:r>
+              <a:rPr lang="en-US" sz="1000" dirty="0">
                 <a:solidFill>
                   <a:srgbClr val="333333"/>
                 </a:solidFill>
@@ -3886,104 +4044,20 @@
                 <a:ea typeface="Calibri" pitchFamily="34" charset="-122"/>
                 <a:cs typeface="Calibri" pitchFamily="34" charset="-120"/>
               </a:rPr>
-              <a:t>¿Cómo quieres recibir el output?</a:t>
-            </a:r>
-            <a:endParaRPr lang="en-US" sz="1050" dirty="0"/>
-          </a:p>
-        </p:txBody>
-      </p:sp>
-      <p:sp>
-        <p:nvSpPr>
-          <p:cNvPr id="17" name="Shape 15"/>
-          <p:cNvSpPr/>
-          <p:nvPr/>
-        </p:nvSpPr>
-        <p:spPr>
-          <a:xfrm>
-            <a:off x="457200" y="3785616"/>
-            <a:ext cx="1280160" cy="347472"/>
-          </a:xfrm>
-          <a:prstGeom prst="rect">
-            <a:avLst/>
-          </a:prstGeom>
-          <a:solidFill>
-            <a:srgbClr val="F4A01C">
-              <a:alpha val="12000"/>
-            </a:srgbClr>
-          </a:solidFill>
-          <a:ln w="10160">
-            <a:solidFill>
-              <a:srgbClr val="F4A01C"/>
-            </a:solidFill>
-            <a:prstDash val="solid"/>
-          </a:ln>
-        </p:spPr>
-      </p:sp>
-      <p:sp>
-        <p:nvSpPr>
-          <p:cNvPr id="18" name="Text 16"/>
-          <p:cNvSpPr/>
-          <p:nvPr/>
-        </p:nvSpPr>
-        <p:spPr>
-          <a:xfrm>
-            <a:off x="457200" y="3785616"/>
-            <a:ext cx="1280160" cy="347472"/>
-          </a:xfrm>
-          <a:prstGeom prst="rect">
-            <a:avLst/>
-          </a:prstGeom>
-          <a:noFill/>
-          <a:ln/>
-        </p:spPr>
-        <p:txBody>
-          <a:bodyPr wrap="square" lIns="0" tIns="0" rIns="0" bIns="0" rtlCol="0" anchor="ctr"/>
-          <a:lstStyle/>
-          <a:p>
-            <a:pPr algn="ctr" indent="0" marL="0">
-              <a:buNone/>
-            </a:pPr>
-            <a:r>
-              <a:rPr lang="en-US" sz="850" b="1" dirty="0">
-                <a:solidFill>
-                  <a:srgbClr val="F4A01C"/>
-                </a:solidFill>
-                <a:latin typeface="Calibri" pitchFamily="34" charset="0"/>
-                <a:ea typeface="Calibri" pitchFamily="34" charset="-122"/>
-                <a:cs typeface="Calibri" pitchFamily="34" charset="-120"/>
-              </a:rPr>
-              <a:t>RESTRICCIONES</a:t>
-            </a:r>
-            <a:endParaRPr lang="en-US" sz="850" dirty="0"/>
-          </a:p>
-        </p:txBody>
-      </p:sp>
-      <p:sp>
-        <p:nvSpPr>
-          <p:cNvPr id="19" name="Text 17"/>
-          <p:cNvSpPr/>
-          <p:nvPr/>
-        </p:nvSpPr>
-        <p:spPr>
-          <a:xfrm>
-            <a:off x="1874520" y="3822192"/>
-            <a:ext cx="3749040" cy="274320"/>
-          </a:xfrm>
-          <a:prstGeom prst="rect">
-            <a:avLst/>
-          </a:prstGeom>
-          <a:noFill/>
-          <a:ln/>
-        </p:spPr>
-        <p:txBody>
-          <a:bodyPr wrap="square" lIns="0" tIns="0" rIns="0" bIns="0" rtlCol="0" anchor="ctr"/>
-          <a:lstStyle/>
-          <a:p>
-            <a:pPr indent="0" marL="0">
-              <a:buNone/>
-            </a:pPr>
-            <a:r>
-              <a:rPr lang="en-US" sz="1050" dirty="0">
+              <a:t>Consulta por tema de unidad con referencia específica</a:t>
+            </a:r>
+            <a:endParaRPr lang="en-US" sz="1000" dirty="0"/>
+          </a:p>
+          <a:p>
+            <a:pPr marL="342900" indent="-342900">
+              <a:spcAft>
+                <a:spcPts val="300"/>
+              </a:spcAft>
+              <a:buSzPct val="100000"/>
+              <a:buChar char="•"/>
+            </a:pPr>
+            <a:r>
+              <a:rPr lang="en-US" sz="1000" dirty="0">
                 <a:solidFill>
                   <a:srgbClr val="333333"/>
                 </a:solidFill>
@@ -3991,30 +4065,93 @@
                 <a:ea typeface="Calibri" pitchFamily="34" charset="-122"/>
                 <a:cs typeface="Calibri" pitchFamily="34" charset="-120"/>
               </a:rPr>
-              <a:t>Límites: tiempo, recursos, nivel de lenguaje</a:t>
-            </a:r>
-            <a:endParaRPr lang="en-US" sz="1050" dirty="0"/>
-          </a:p>
-        </p:txBody>
-      </p:sp>
-      <p:sp>
-        <p:nvSpPr>
-          <p:cNvPr id="20" name="Shape 18"/>
-          <p:cNvSpPr/>
-          <p:nvPr/>
-        </p:nvSpPr>
-        <p:spPr>
-          <a:xfrm>
-            <a:off x="5852160" y="1051560"/>
-            <a:ext cx="2834640" cy="3703320"/>
-          </a:xfrm>
-          <a:prstGeom prst="rect">
+              <a:t>Itera para adaptar el lenguaje a tu audiencia</a:t>
+            </a:r>
+            <a:endParaRPr lang="en-US" sz="1000" dirty="0"/>
+          </a:p>
+          <a:p>
+            <a:pPr marL="342900" indent="-342900">
+              <a:spcAft>
+                <a:spcPts val="300"/>
+              </a:spcAft>
+              <a:buSzPct val="100000"/>
+              <a:buChar char="•"/>
+            </a:pPr>
+            <a:r>
+              <a:rPr lang="en-US" sz="1000" dirty="0">
+                <a:solidFill>
+                  <a:srgbClr val="333333"/>
+                </a:solidFill>
+                <a:latin typeface="Calibri" pitchFamily="34" charset="0"/>
+                <a:ea typeface="Calibri" pitchFamily="34" charset="-122"/>
+                <a:cs typeface="Calibri" pitchFamily="34" charset="-120"/>
+              </a:rPr>
+              <a:t>Exporta outputs a Google Docs en tu Drive</a:t>
+            </a:r>
+            <a:endParaRPr lang="en-US" sz="1000" dirty="0"/>
+          </a:p>
+          <a:p>
+            <a:pPr marL="342900" indent="-342900">
+              <a:spcAft>
+                <a:spcPts val="300"/>
+              </a:spcAft>
+              <a:buSzPct val="100000"/>
+              <a:buChar char="•"/>
+            </a:pPr>
+            <a:r>
+              <a:rPr lang="en-US" sz="1000" dirty="0">
+                <a:solidFill>
+                  <a:srgbClr val="333333"/>
+                </a:solidFill>
+                <a:latin typeface="Calibri" pitchFamily="34" charset="0"/>
+                <a:ea typeface="Calibri" pitchFamily="34" charset="-122"/>
+                <a:cs typeface="Calibri" pitchFamily="34" charset="-120"/>
+              </a:rPr>
+              <a:t>Añade el Doc como fuente en NotebookLM</a:t>
+            </a:r>
+            <a:endParaRPr lang="en-US" sz="1000" dirty="0"/>
+          </a:p>
+          <a:p>
+            <a:pPr marL="342900" indent="-342900">
+              <a:spcAft>
+                <a:spcPts val="300"/>
+              </a:spcAft>
+              <a:buSzPct val="100000"/>
+              <a:buChar char="•"/>
+            </a:pPr>
+            <a:r>
+              <a:rPr lang="en-US" sz="1000" dirty="0">
+                <a:solidFill>
+                  <a:srgbClr val="333333"/>
+                </a:solidFill>
+                <a:latin typeface="Calibri" pitchFamily="34" charset="0"/>
+                <a:ea typeface="Calibri" pitchFamily="34" charset="-122"/>
+                <a:cs typeface="Calibri" pitchFamily="34" charset="-120"/>
+              </a:rPr>
+              <a:t>Siempre verifica citas en la fuente original</a:t>
+            </a:r>
+            <a:endParaRPr lang="en-US" sz="1000" dirty="0"/>
+          </a:p>
+        </p:txBody>
+      </p:sp>
+      <p:sp>
+        <p:nvSpPr>
+          <p:cNvPr id="15" name="Shape 13"/>
+          <p:cNvSpPr/>
+          <p:nvPr/>
+        </p:nvSpPr>
+        <p:spPr>
+          <a:xfrm>
+            <a:off x="4224528" y="2377440"/>
+            <a:ext cx="502920" cy="502920"/>
+          </a:xfrm>
+          <a:prstGeom prst="ellipse">
             <a:avLst/>
           </a:prstGeom>
           <a:solidFill>
             <a:srgbClr val="F2F2F2"/>
           </a:solidFill>
-          <a:ln w="6350">
+          <a:ln w="12700">
             <a:solidFill>
               <a:srgbClr val="E4E4E4"/>
             </a:solidFill>
@@ -4024,53 +4161,53 @@
       </p:sp>
       <p:sp>
         <p:nvSpPr>
-          <p:cNvPr id="21" name="Text 19"/>
-          <p:cNvSpPr/>
-          <p:nvPr/>
-        </p:nvSpPr>
-        <p:spPr>
-          <a:xfrm>
-            <a:off x="5943600" y="1143000"/>
-            <a:ext cx="1234440" cy="201168"/>
-          </a:xfrm>
-          <a:prstGeom prst="rect">
-            <a:avLst/>
-          </a:prstGeom>
-          <a:noFill/>
-          <a:ln/>
-        </p:spPr>
-        <p:txBody>
-          <a:bodyPr wrap="square" lIns="0" tIns="0" rIns="0" bIns="0" rtlCol="0" anchor="ctr"/>
-          <a:lstStyle/>
-          <a:p>
-            <a:pPr indent="0" marL="0">
-              <a:buNone/>
-            </a:pPr>
-            <a:r>
-              <a:rPr lang="en-US" sz="700" b="1" spc="100" kern="0" dirty="0">
-                <a:solidFill>
-                  <a:srgbClr val="E05C5C"/>
-                </a:solidFill>
-                <a:latin typeface="Calibri" pitchFamily="34" charset="0"/>
-                <a:ea typeface="Calibri" pitchFamily="34" charset="-122"/>
-                <a:cs typeface="Calibri" pitchFamily="34" charset="-120"/>
-              </a:rPr>
-              <a:t>SIN CONTEXTO</a:t>
-            </a:r>
-            <a:endParaRPr lang="en-US" sz="700" dirty="0"/>
-          </a:p>
-        </p:txBody>
-      </p:sp>
-      <p:sp>
-        <p:nvSpPr>
-          <p:cNvPr id="22" name="Shape 20"/>
-          <p:cNvSpPr/>
-          <p:nvPr/>
-        </p:nvSpPr>
-        <p:spPr>
-          <a:xfrm>
-            <a:off x="5943600" y="1371600"/>
-            <a:ext cx="2651760" cy="1005840"/>
+          <p:cNvPr id="16" name="Text 14"/>
+          <p:cNvSpPr/>
+          <p:nvPr/>
+        </p:nvSpPr>
+        <p:spPr>
+          <a:xfrm>
+            <a:off x="4224528" y="2377440"/>
+            <a:ext cx="502920" cy="502920"/>
+          </a:xfrm>
+          <a:prstGeom prst="rect">
+            <a:avLst/>
+          </a:prstGeom>
+          <a:noFill/>
+          <a:ln/>
+        </p:spPr>
+        <p:txBody>
+          <a:bodyPr wrap="square" lIns="0" tIns="0" rIns="0" bIns="0" rtlCol="0" anchor="ctr"/>
+          <a:lstStyle/>
+          <a:p>
+            <a:pPr algn="ctr" indent="0" marL="0">
+              <a:buNone/>
+            </a:pPr>
+            <a:r>
+              <a:rPr lang="en-US" sz="1400" b="1" dirty="0">
+                <a:solidFill>
+                  <a:srgbClr val="666666"/>
+                </a:solidFill>
+                <a:latin typeface="Trebuchet MS" pitchFamily="34" charset="0"/>
+                <a:ea typeface="Trebuchet MS" pitchFamily="34" charset="-122"/>
+                <a:cs typeface="Trebuchet MS" pitchFamily="34" charset="-120"/>
+              </a:rPr>
+              <a:t>+</a:t>
+            </a:r>
+            <a:endParaRPr lang="en-US" sz="1400" dirty="0"/>
+          </a:p>
+        </p:txBody>
+      </p:sp>
+      <p:sp>
+        <p:nvSpPr>
+          <p:cNvPr id="17" name="Shape 15"/>
+          <p:cNvSpPr/>
+          <p:nvPr/>
+        </p:nvSpPr>
+        <p:spPr>
+          <a:xfrm>
+            <a:off x="457200" y="4572000"/>
+            <a:ext cx="8229600" cy="246888"/>
           </a:xfrm>
           <a:prstGeom prst="rect">
             <a:avLst/>
@@ -4088,149 +4225,46 @@
       </p:sp>
       <p:sp>
         <p:nvSpPr>
-          <p:cNvPr id="23" name="Text 21"/>
-          <p:cNvSpPr/>
-          <p:nvPr/>
-        </p:nvSpPr>
-        <p:spPr>
-          <a:xfrm>
-            <a:off x="5989320" y="1417320"/>
-            <a:ext cx="2560320" cy="914400"/>
-          </a:xfrm>
-          <a:prstGeom prst="rect">
-            <a:avLst/>
-          </a:prstGeom>
-          <a:noFill/>
-          <a:ln/>
-        </p:spPr>
-        <p:txBody>
-          <a:bodyPr wrap="square" lIns="0" tIns="0" rIns="0" bIns="0" rtlCol="0" anchor="ctr"/>
-          <a:lstStyle/>
-          <a:p>
-            <a:pPr indent="0" marL="0">
-              <a:buNone/>
-            </a:pPr>
-            <a:r>
-              <a:rPr lang="en-US" sz="950" i="1" dirty="0">
-                <a:solidFill>
-                  <a:srgbClr val="8A3030"/>
-                </a:solidFill>
-                <a:latin typeface="Calibri" pitchFamily="34" charset="0"/>
-                <a:ea typeface="Calibri" pitchFamily="34" charset="-122"/>
-                <a:cs typeface="Calibri" pitchFamily="34" charset="-120"/>
-              </a:rPr>
-              <a:t>"Hazme un plan de clase sobre los sacramentos."</a:t>
-            </a:r>
-            <a:endParaRPr lang="en-US" sz="950" dirty="0"/>
-          </a:p>
-        </p:txBody>
-      </p:sp>
-      <p:sp>
-        <p:nvSpPr>
-          <p:cNvPr id="24" name="Text 22"/>
-          <p:cNvSpPr/>
-          <p:nvPr/>
-        </p:nvSpPr>
-        <p:spPr>
-          <a:xfrm>
-            <a:off x="5943600" y="2487168"/>
-            <a:ext cx="1371600" cy="201168"/>
-          </a:xfrm>
-          <a:prstGeom prst="rect">
-            <a:avLst/>
-          </a:prstGeom>
-          <a:noFill/>
-          <a:ln/>
-        </p:spPr>
-        <p:txBody>
-          <a:bodyPr wrap="square" lIns="0" tIns="0" rIns="0" bIns="0" rtlCol="0" anchor="ctr"/>
-          <a:lstStyle/>
-          <a:p>
-            <a:pPr indent="0" marL="0">
-              <a:buNone/>
-            </a:pPr>
-            <a:r>
-              <a:rPr lang="en-US" sz="700" b="1" spc="100" kern="0" dirty="0">
-                <a:solidFill>
-                  <a:srgbClr val="2DC653"/>
-                </a:solidFill>
-                <a:latin typeface="Calibri" pitchFamily="34" charset="0"/>
-                <a:ea typeface="Calibri" pitchFamily="34" charset="-122"/>
-                <a:cs typeface="Calibri" pitchFamily="34" charset="-120"/>
-              </a:rPr>
-              <a:t>CON CONTEXTO</a:t>
-            </a:r>
-            <a:endParaRPr lang="en-US" sz="700" dirty="0"/>
-          </a:p>
-        </p:txBody>
-      </p:sp>
-      <p:sp>
-        <p:nvSpPr>
-          <p:cNvPr id="25" name="Shape 23"/>
-          <p:cNvSpPr/>
-          <p:nvPr/>
-        </p:nvSpPr>
-        <p:spPr>
-          <a:xfrm>
-            <a:off x="5943600" y="2706624"/>
-            <a:ext cx="2651760" cy="1920240"/>
-          </a:xfrm>
-          <a:prstGeom prst="rect">
-            <a:avLst/>
-          </a:prstGeom>
-          <a:solidFill>
-            <a:srgbClr val="F0FFF4"/>
-          </a:solidFill>
-          <a:ln w="6350">
-            <a:solidFill>
-              <a:srgbClr val="B8DECA"/>
-            </a:solidFill>
-            <a:prstDash val="solid"/>
-          </a:ln>
-        </p:spPr>
-      </p:sp>
-      <p:sp>
-        <p:nvSpPr>
-          <p:cNvPr id="26" name="Text 24"/>
-          <p:cNvSpPr/>
-          <p:nvPr/>
-        </p:nvSpPr>
-        <p:spPr>
-          <a:xfrm>
-            <a:off x="5989320" y="2752344"/>
-            <a:ext cx="2560320" cy="1828800"/>
-          </a:xfrm>
-          <a:prstGeom prst="rect">
-            <a:avLst/>
-          </a:prstGeom>
-          <a:noFill/>
-          <a:ln/>
-        </p:spPr>
-        <p:txBody>
-          <a:bodyPr wrap="square" lIns="0" tIns="0" rIns="0" bIns="0" rtlCol="0" anchor="t"/>
-          <a:lstStyle/>
-          <a:p>
-            <a:pPr indent="0" marL="0">
-              <a:buNone/>
-            </a:pPr>
-            <a:r>
-              <a:rPr lang="en-US" sz="850" dirty="0">
-                <a:solidFill>
-                  <a:srgbClr val="1A3528"/>
-                </a:solidFill>
-                <a:latin typeface="Calibri" pitchFamily="34" charset="0"/>
-                <a:ea typeface="Calibri" pitchFamily="34" charset="-122"/>
-                <a:cs typeface="Calibri" pitchFamily="34" charset="-120"/>
-              </a:rPr>
-              <a:t>"Actúa como asistente de religión K-12. Estoy planificando Sacramentos en 9no. Objetivo: que el estudiante los viva como encuentro, no como ritual (CIC 1084). Estudiantes de 14-15 años, buscan autenticidad. Genera un hook de 10 min."</a:t>
-            </a:r>
-            <a:endParaRPr lang="en-US" sz="850" dirty="0"/>
-          </a:p>
-        </p:txBody>
-      </p:sp>
-      <p:sp>
-        <p:nvSpPr>
-          <p:cNvPr id="27" name="Text 25"/>
+          <p:cNvPr id="18" name="Text 16"/>
+          <p:cNvSpPr/>
+          <p:nvPr/>
+        </p:nvSpPr>
+        <p:spPr>
+          <a:xfrm>
+            <a:off x="457200" y="4572000"/>
+            <a:ext cx="8229600" cy="246888"/>
+          </a:xfrm>
+          <a:prstGeom prst="rect">
+            <a:avLst/>
+          </a:prstGeom>
+          <a:noFill/>
+          <a:ln/>
+        </p:spPr>
+        <p:txBody>
+          <a:bodyPr wrap="square" lIns="0" tIns="0" rIns="0" bIns="0" rtlCol="0" anchor="ctr"/>
+          <a:lstStyle/>
+          <a:p>
+            <a:pPr algn="ctr" indent="0" marL="0">
+              <a:buNone/>
+            </a:pPr>
+            <a:r>
+              <a:rPr lang="en-US" sz="900" b="1" dirty="0">
+                <a:solidFill>
+                  <a:srgbClr val="E05C5C"/>
+                </a:solidFill>
+                <a:latin typeface="Calibri" pitchFamily="34" charset="0"/>
+                <a:ea typeface="Calibri" pitchFamily="34" charset="-122"/>
+                <a:cs typeface="Calibri" pitchFamily="34" charset="-120"/>
+              </a:rPr>
+              <a:t>⚠  Verifica siempre las citas doctrinales en la fuente original antes de usarlas en clase</a:t>
+            </a:r>
+            <a:endParaRPr lang="en-US" sz="900" dirty="0"/>
+          </a:p>
+        </p:txBody>
+      </p:sp>
+      <p:sp>
+        <p:nvSpPr>
+          <p:cNvPr id="19" name="Text 17"/>
           <p:cNvSpPr/>
           <p:nvPr/>
         </p:nvSpPr>
@@ -4357,6 +4391,936 @@
                 <a:ea typeface="Calibri" pitchFamily="34" charset="-122"/>
                 <a:cs typeface="Calibri" pitchFamily="34" charset="-120"/>
               </a:rPr>
+              <a:t>FUNDAMENTO · EL PROMPT</a:t>
+            </a:r>
+            <a:endParaRPr lang="en-US" sz="850" dirty="0"/>
+          </a:p>
+        </p:txBody>
+      </p:sp>
+      <p:sp>
+        <p:nvSpPr>
+          <p:cNvPr id="4" name="Text 2"/>
+          <p:cNvSpPr/>
+          <p:nvPr/>
+        </p:nvSpPr>
+        <p:spPr>
+          <a:xfrm>
+            <a:off x="457200" y="457200"/>
+            <a:ext cx="8229600" cy="502920"/>
+          </a:xfrm>
+          <a:prstGeom prst="rect">
+            <a:avLst/>
+          </a:prstGeom>
+          <a:noFill/>
+          <a:ln/>
+        </p:spPr>
+        <p:txBody>
+          <a:bodyPr wrap="square" lIns="0" tIns="0" rIns="0" bIns="0" rtlCol="0" anchor="ctr"/>
+          <a:lstStyle/>
+          <a:p>
+            <a:pPr indent="0" marL="0">
+              <a:buNone/>
+            </a:pPr>
+            <a:r>
+              <a:rPr lang="en-US" sz="2600" b="1" dirty="0">
+                <a:solidFill>
+                  <a:srgbClr val="333333"/>
+                </a:solidFill>
+                <a:latin typeface="Trebuchet MS" pitchFamily="34" charset="0"/>
+                <a:ea typeface="Trebuchet MS" pitchFamily="34" charset="-122"/>
+                <a:cs typeface="Trebuchet MS" pitchFamily="34" charset="-120"/>
+              </a:rPr>
+              <a:t>El prompt no es magia — es contexto</a:t>
+            </a:r>
+            <a:endParaRPr lang="en-US" sz="2600" dirty="0"/>
+          </a:p>
+        </p:txBody>
+      </p:sp>
+      <p:sp>
+        <p:nvSpPr>
+          <p:cNvPr id="5" name="Shape 3"/>
+          <p:cNvSpPr/>
+          <p:nvPr/>
+        </p:nvSpPr>
+        <p:spPr>
+          <a:xfrm>
+            <a:off x="457200" y="1115568"/>
+            <a:ext cx="1280160" cy="347472"/>
+          </a:xfrm>
+          <a:prstGeom prst="rect">
+            <a:avLst/>
+          </a:prstGeom>
+          <a:solidFill>
+            <a:srgbClr val="00B4D8">
+              <a:alpha val="12000"/>
+            </a:srgbClr>
+          </a:solidFill>
+          <a:ln w="10160">
+            <a:solidFill>
+              <a:srgbClr val="00B4D8"/>
+            </a:solidFill>
+            <a:prstDash val="solid"/>
+          </a:ln>
+        </p:spPr>
+      </p:sp>
+      <p:sp>
+        <p:nvSpPr>
+          <p:cNvPr id="6" name="Text 4"/>
+          <p:cNvSpPr/>
+          <p:nvPr/>
+        </p:nvSpPr>
+        <p:spPr>
+          <a:xfrm>
+            <a:off x="457200" y="1115568"/>
+            <a:ext cx="1280160" cy="347472"/>
+          </a:xfrm>
+          <a:prstGeom prst="rect">
+            <a:avLst/>
+          </a:prstGeom>
+          <a:noFill/>
+          <a:ln/>
+        </p:spPr>
+        <p:txBody>
+          <a:bodyPr wrap="square" lIns="0" tIns="0" rIns="0" bIns="0" rtlCol="0" anchor="ctr"/>
+          <a:lstStyle/>
+          <a:p>
+            <a:pPr algn="ctr" indent="0" marL="0">
+              <a:buNone/>
+            </a:pPr>
+            <a:r>
+              <a:rPr lang="en-US" sz="850" b="1" dirty="0">
+                <a:solidFill>
+                  <a:srgbClr val="00B4D8"/>
+                </a:solidFill>
+                <a:latin typeface="Calibri" pitchFamily="34" charset="0"/>
+                <a:ea typeface="Calibri" pitchFamily="34" charset="-122"/>
+                <a:cs typeface="Calibri" pitchFamily="34" charset="-120"/>
+              </a:rPr>
+              <a:t>ROL</a:t>
+            </a:r>
+            <a:endParaRPr lang="en-US" sz="850" dirty="0"/>
+          </a:p>
+        </p:txBody>
+      </p:sp>
+      <p:sp>
+        <p:nvSpPr>
+          <p:cNvPr id="7" name="Text 5"/>
+          <p:cNvSpPr/>
+          <p:nvPr/>
+        </p:nvSpPr>
+        <p:spPr>
+          <a:xfrm>
+            <a:off x="1874520" y="1152144"/>
+            <a:ext cx="3749040" cy="274320"/>
+          </a:xfrm>
+          <a:prstGeom prst="rect">
+            <a:avLst/>
+          </a:prstGeom>
+          <a:noFill/>
+          <a:ln/>
+        </p:spPr>
+        <p:txBody>
+          <a:bodyPr wrap="square" lIns="0" tIns="0" rIns="0" bIns="0" rtlCol="0" anchor="ctr"/>
+          <a:lstStyle/>
+          <a:p>
+            <a:pPr indent="0" marL="0">
+              <a:buNone/>
+            </a:pPr>
+            <a:r>
+              <a:rPr lang="en-US" sz="1050" dirty="0">
+                <a:solidFill>
+                  <a:srgbClr val="333333"/>
+                </a:solidFill>
+                <a:latin typeface="Calibri" pitchFamily="34" charset="0"/>
+                <a:ea typeface="Calibri" pitchFamily="34" charset="-122"/>
+                <a:cs typeface="Calibri" pitchFamily="34" charset="-120"/>
+              </a:rPr>
+              <a:t>¿Quién es la IA en esta conversación?</a:t>
+            </a:r>
+            <a:endParaRPr lang="en-US" sz="1050" dirty="0"/>
+          </a:p>
+        </p:txBody>
+      </p:sp>
+      <p:sp>
+        <p:nvSpPr>
+          <p:cNvPr id="8" name="Shape 6"/>
+          <p:cNvSpPr/>
+          <p:nvPr/>
+        </p:nvSpPr>
+        <p:spPr>
+          <a:xfrm>
+            <a:off x="457200" y="1783080"/>
+            <a:ext cx="1280160" cy="347472"/>
+          </a:xfrm>
+          <a:prstGeom prst="rect">
+            <a:avLst/>
+          </a:prstGeom>
+          <a:solidFill>
+            <a:srgbClr val="0096B7">
+              <a:alpha val="12000"/>
+            </a:srgbClr>
+          </a:solidFill>
+          <a:ln w="10160">
+            <a:solidFill>
+              <a:srgbClr val="0096B7"/>
+            </a:solidFill>
+            <a:prstDash val="solid"/>
+          </a:ln>
+        </p:spPr>
+      </p:sp>
+      <p:sp>
+        <p:nvSpPr>
+          <p:cNvPr id="9" name="Text 7"/>
+          <p:cNvSpPr/>
+          <p:nvPr/>
+        </p:nvSpPr>
+        <p:spPr>
+          <a:xfrm>
+            <a:off x="457200" y="1783080"/>
+            <a:ext cx="1280160" cy="347472"/>
+          </a:xfrm>
+          <a:prstGeom prst="rect">
+            <a:avLst/>
+          </a:prstGeom>
+          <a:noFill/>
+          <a:ln/>
+        </p:spPr>
+        <p:txBody>
+          <a:bodyPr wrap="square" lIns="0" tIns="0" rIns="0" bIns="0" rtlCol="0" anchor="ctr"/>
+          <a:lstStyle/>
+          <a:p>
+            <a:pPr algn="ctr" indent="0" marL="0">
+              <a:buNone/>
+            </a:pPr>
+            <a:r>
+              <a:rPr lang="en-US" sz="850" b="1" dirty="0">
+                <a:solidFill>
+                  <a:srgbClr val="0096B7"/>
+                </a:solidFill>
+                <a:latin typeface="Calibri" pitchFamily="34" charset="0"/>
+                <a:ea typeface="Calibri" pitchFamily="34" charset="-122"/>
+                <a:cs typeface="Calibri" pitchFamily="34" charset="-120"/>
+              </a:rPr>
+              <a:t>CONTEXTO</a:t>
+            </a:r>
+            <a:endParaRPr lang="en-US" sz="850" dirty="0"/>
+          </a:p>
+        </p:txBody>
+      </p:sp>
+      <p:sp>
+        <p:nvSpPr>
+          <p:cNvPr id="10" name="Text 8"/>
+          <p:cNvSpPr/>
+          <p:nvPr/>
+        </p:nvSpPr>
+        <p:spPr>
+          <a:xfrm>
+            <a:off x="1874520" y="1819656"/>
+            <a:ext cx="3749040" cy="274320"/>
+          </a:xfrm>
+          <a:prstGeom prst="rect">
+            <a:avLst/>
+          </a:prstGeom>
+          <a:noFill/>
+          <a:ln/>
+        </p:spPr>
+        <p:txBody>
+          <a:bodyPr wrap="square" lIns="0" tIns="0" rIns="0" bIns="0" rtlCol="0" anchor="ctr"/>
+          <a:lstStyle/>
+          <a:p>
+            <a:pPr indent="0" marL="0">
+              <a:buNone/>
+            </a:pPr>
+            <a:r>
+              <a:rPr lang="en-US" sz="1050" dirty="0">
+                <a:solidFill>
+                  <a:srgbClr val="333333"/>
+                </a:solidFill>
+                <a:latin typeface="Calibri" pitchFamily="34" charset="0"/>
+                <a:ea typeface="Calibri" pitchFamily="34" charset="-122"/>
+                <a:cs typeface="Calibri" pitchFamily="34" charset="-120"/>
+              </a:rPr>
+              <a:t>Grado · Tema · Estándar · Doctrina · Perfil del estudiante</a:t>
+            </a:r>
+            <a:endParaRPr lang="en-US" sz="1050" dirty="0"/>
+          </a:p>
+        </p:txBody>
+      </p:sp>
+      <p:sp>
+        <p:nvSpPr>
+          <p:cNvPr id="11" name="Shape 9"/>
+          <p:cNvSpPr/>
+          <p:nvPr/>
+        </p:nvSpPr>
+        <p:spPr>
+          <a:xfrm>
+            <a:off x="457200" y="2450592"/>
+            <a:ext cx="1280160" cy="347472"/>
+          </a:xfrm>
+          <a:prstGeom prst="rect">
+            <a:avLst/>
+          </a:prstGeom>
+          <a:solidFill>
+            <a:srgbClr val="2DC653">
+              <a:alpha val="12000"/>
+            </a:srgbClr>
+          </a:solidFill>
+          <a:ln w="10160">
+            <a:solidFill>
+              <a:srgbClr val="2DC653"/>
+            </a:solidFill>
+            <a:prstDash val="solid"/>
+          </a:ln>
+        </p:spPr>
+      </p:sp>
+      <p:sp>
+        <p:nvSpPr>
+          <p:cNvPr id="12" name="Text 10"/>
+          <p:cNvSpPr/>
+          <p:nvPr/>
+        </p:nvSpPr>
+        <p:spPr>
+          <a:xfrm>
+            <a:off x="457200" y="2450592"/>
+            <a:ext cx="1280160" cy="347472"/>
+          </a:xfrm>
+          <a:prstGeom prst="rect">
+            <a:avLst/>
+          </a:prstGeom>
+          <a:noFill/>
+          <a:ln/>
+        </p:spPr>
+        <p:txBody>
+          <a:bodyPr wrap="square" lIns="0" tIns="0" rIns="0" bIns="0" rtlCol="0" anchor="ctr"/>
+          <a:lstStyle/>
+          <a:p>
+            <a:pPr algn="ctr" indent="0" marL="0">
+              <a:buNone/>
+            </a:pPr>
+            <a:r>
+              <a:rPr lang="en-US" sz="850" b="1" dirty="0">
+                <a:solidFill>
+                  <a:srgbClr val="2DC653"/>
+                </a:solidFill>
+                <a:latin typeface="Calibri" pitchFamily="34" charset="0"/>
+                <a:ea typeface="Calibri" pitchFamily="34" charset="-122"/>
+                <a:cs typeface="Calibri" pitchFamily="34" charset="-120"/>
+              </a:rPr>
+              <a:t>TAREA</a:t>
+            </a:r>
+            <a:endParaRPr lang="en-US" sz="850" dirty="0"/>
+          </a:p>
+        </p:txBody>
+      </p:sp>
+      <p:sp>
+        <p:nvSpPr>
+          <p:cNvPr id="13" name="Text 11"/>
+          <p:cNvSpPr/>
+          <p:nvPr/>
+        </p:nvSpPr>
+        <p:spPr>
+          <a:xfrm>
+            <a:off x="1874520" y="2487168"/>
+            <a:ext cx="3749040" cy="274320"/>
+          </a:xfrm>
+          <a:prstGeom prst="rect">
+            <a:avLst/>
+          </a:prstGeom>
+          <a:noFill/>
+          <a:ln/>
+        </p:spPr>
+        <p:txBody>
+          <a:bodyPr wrap="square" lIns="0" tIns="0" rIns="0" bIns="0" rtlCol="0" anchor="ctr"/>
+          <a:lstStyle/>
+          <a:p>
+            <a:pPr indent="0" marL="0">
+              <a:buNone/>
+            </a:pPr>
+            <a:r>
+              <a:rPr lang="en-US" sz="1050" dirty="0">
+                <a:solidFill>
+                  <a:srgbClr val="333333"/>
+                </a:solidFill>
+                <a:latin typeface="Calibri" pitchFamily="34" charset="0"/>
+                <a:ea typeface="Calibri" pitchFamily="34" charset="-122"/>
+                <a:cs typeface="Calibri" pitchFamily="34" charset="-120"/>
+              </a:rPr>
+              <a:t>¿Qué quieres que genere exactamente?</a:t>
+            </a:r>
+            <a:endParaRPr lang="en-US" sz="1050" dirty="0"/>
+          </a:p>
+        </p:txBody>
+      </p:sp>
+      <p:sp>
+        <p:nvSpPr>
+          <p:cNvPr id="14" name="Shape 12"/>
+          <p:cNvSpPr/>
+          <p:nvPr/>
+        </p:nvSpPr>
+        <p:spPr>
+          <a:xfrm>
+            <a:off x="457200" y="3118104"/>
+            <a:ext cx="1280160" cy="347472"/>
+          </a:xfrm>
+          <a:prstGeom prst="rect">
+            <a:avLst/>
+          </a:prstGeom>
+          <a:solidFill>
+            <a:srgbClr val="7B5EA7">
+              <a:alpha val="12000"/>
+            </a:srgbClr>
+          </a:solidFill>
+          <a:ln w="10160">
+            <a:solidFill>
+              <a:srgbClr val="7B5EA7"/>
+            </a:solidFill>
+            <a:prstDash val="solid"/>
+          </a:ln>
+        </p:spPr>
+      </p:sp>
+      <p:sp>
+        <p:nvSpPr>
+          <p:cNvPr id="15" name="Text 13"/>
+          <p:cNvSpPr/>
+          <p:nvPr/>
+        </p:nvSpPr>
+        <p:spPr>
+          <a:xfrm>
+            <a:off x="457200" y="3118104"/>
+            <a:ext cx="1280160" cy="347472"/>
+          </a:xfrm>
+          <a:prstGeom prst="rect">
+            <a:avLst/>
+          </a:prstGeom>
+          <a:noFill/>
+          <a:ln/>
+        </p:spPr>
+        <p:txBody>
+          <a:bodyPr wrap="square" lIns="0" tIns="0" rIns="0" bIns="0" rtlCol="0" anchor="ctr"/>
+          <a:lstStyle/>
+          <a:p>
+            <a:pPr algn="ctr" indent="0" marL="0">
+              <a:buNone/>
+            </a:pPr>
+            <a:r>
+              <a:rPr lang="en-US" sz="850" b="1" dirty="0">
+                <a:solidFill>
+                  <a:srgbClr val="7B5EA7"/>
+                </a:solidFill>
+                <a:latin typeface="Calibri" pitchFamily="34" charset="0"/>
+                <a:ea typeface="Calibri" pitchFamily="34" charset="-122"/>
+                <a:cs typeface="Calibri" pitchFamily="34" charset="-120"/>
+              </a:rPr>
+              <a:t>FORMATO</a:t>
+            </a:r>
+            <a:endParaRPr lang="en-US" sz="850" dirty="0"/>
+          </a:p>
+        </p:txBody>
+      </p:sp>
+      <p:sp>
+        <p:nvSpPr>
+          <p:cNvPr id="16" name="Text 14"/>
+          <p:cNvSpPr/>
+          <p:nvPr/>
+        </p:nvSpPr>
+        <p:spPr>
+          <a:xfrm>
+            <a:off x="1874520" y="3154680"/>
+            <a:ext cx="3749040" cy="274320"/>
+          </a:xfrm>
+          <a:prstGeom prst="rect">
+            <a:avLst/>
+          </a:prstGeom>
+          <a:noFill/>
+          <a:ln/>
+        </p:spPr>
+        <p:txBody>
+          <a:bodyPr wrap="square" lIns="0" tIns="0" rIns="0" bIns="0" rtlCol="0" anchor="ctr"/>
+          <a:lstStyle/>
+          <a:p>
+            <a:pPr indent="0" marL="0">
+              <a:buNone/>
+            </a:pPr>
+            <a:r>
+              <a:rPr lang="en-US" sz="1050" dirty="0">
+                <a:solidFill>
+                  <a:srgbClr val="333333"/>
+                </a:solidFill>
+                <a:latin typeface="Calibri" pitchFamily="34" charset="0"/>
+                <a:ea typeface="Calibri" pitchFamily="34" charset="-122"/>
+                <a:cs typeface="Calibri" pitchFamily="34" charset="-120"/>
+              </a:rPr>
+              <a:t>¿Cómo quieres recibir el output?</a:t>
+            </a:r>
+            <a:endParaRPr lang="en-US" sz="1050" dirty="0"/>
+          </a:p>
+        </p:txBody>
+      </p:sp>
+      <p:sp>
+        <p:nvSpPr>
+          <p:cNvPr id="17" name="Shape 15"/>
+          <p:cNvSpPr/>
+          <p:nvPr/>
+        </p:nvSpPr>
+        <p:spPr>
+          <a:xfrm>
+            <a:off x="457200" y="3785616"/>
+            <a:ext cx="1280160" cy="347472"/>
+          </a:xfrm>
+          <a:prstGeom prst="rect">
+            <a:avLst/>
+          </a:prstGeom>
+          <a:solidFill>
+            <a:srgbClr val="F4A01C">
+              <a:alpha val="12000"/>
+            </a:srgbClr>
+          </a:solidFill>
+          <a:ln w="10160">
+            <a:solidFill>
+              <a:srgbClr val="F4A01C"/>
+            </a:solidFill>
+            <a:prstDash val="solid"/>
+          </a:ln>
+        </p:spPr>
+      </p:sp>
+      <p:sp>
+        <p:nvSpPr>
+          <p:cNvPr id="18" name="Text 16"/>
+          <p:cNvSpPr/>
+          <p:nvPr/>
+        </p:nvSpPr>
+        <p:spPr>
+          <a:xfrm>
+            <a:off x="457200" y="3785616"/>
+            <a:ext cx="1280160" cy="347472"/>
+          </a:xfrm>
+          <a:prstGeom prst="rect">
+            <a:avLst/>
+          </a:prstGeom>
+          <a:noFill/>
+          <a:ln/>
+        </p:spPr>
+        <p:txBody>
+          <a:bodyPr wrap="square" lIns="0" tIns="0" rIns="0" bIns="0" rtlCol="0" anchor="ctr"/>
+          <a:lstStyle/>
+          <a:p>
+            <a:pPr algn="ctr" indent="0" marL="0">
+              <a:buNone/>
+            </a:pPr>
+            <a:r>
+              <a:rPr lang="en-US" sz="850" b="1" dirty="0">
+                <a:solidFill>
+                  <a:srgbClr val="F4A01C"/>
+                </a:solidFill>
+                <a:latin typeface="Calibri" pitchFamily="34" charset="0"/>
+                <a:ea typeface="Calibri" pitchFamily="34" charset="-122"/>
+                <a:cs typeface="Calibri" pitchFamily="34" charset="-120"/>
+              </a:rPr>
+              <a:t>RESTRICCIONES</a:t>
+            </a:r>
+            <a:endParaRPr lang="en-US" sz="850" dirty="0"/>
+          </a:p>
+        </p:txBody>
+      </p:sp>
+      <p:sp>
+        <p:nvSpPr>
+          <p:cNvPr id="19" name="Text 17"/>
+          <p:cNvSpPr/>
+          <p:nvPr/>
+        </p:nvSpPr>
+        <p:spPr>
+          <a:xfrm>
+            <a:off x="1874520" y="3822192"/>
+            <a:ext cx="3749040" cy="274320"/>
+          </a:xfrm>
+          <a:prstGeom prst="rect">
+            <a:avLst/>
+          </a:prstGeom>
+          <a:noFill/>
+          <a:ln/>
+        </p:spPr>
+        <p:txBody>
+          <a:bodyPr wrap="square" lIns="0" tIns="0" rIns="0" bIns="0" rtlCol="0" anchor="ctr"/>
+          <a:lstStyle/>
+          <a:p>
+            <a:pPr indent="0" marL="0">
+              <a:buNone/>
+            </a:pPr>
+            <a:r>
+              <a:rPr lang="en-US" sz="1050" dirty="0">
+                <a:solidFill>
+                  <a:srgbClr val="333333"/>
+                </a:solidFill>
+                <a:latin typeface="Calibri" pitchFamily="34" charset="0"/>
+                <a:ea typeface="Calibri" pitchFamily="34" charset="-122"/>
+                <a:cs typeface="Calibri" pitchFamily="34" charset="-120"/>
+              </a:rPr>
+              <a:t>Límites: tiempo, recursos, nivel de lenguaje</a:t>
+            </a:r>
+            <a:endParaRPr lang="en-US" sz="1050" dirty="0"/>
+          </a:p>
+        </p:txBody>
+      </p:sp>
+      <p:sp>
+        <p:nvSpPr>
+          <p:cNvPr id="20" name="Shape 18"/>
+          <p:cNvSpPr/>
+          <p:nvPr/>
+        </p:nvSpPr>
+        <p:spPr>
+          <a:xfrm>
+            <a:off x="5852160" y="1051560"/>
+            <a:ext cx="2834640" cy="3703320"/>
+          </a:xfrm>
+          <a:prstGeom prst="rect">
+            <a:avLst/>
+          </a:prstGeom>
+          <a:solidFill>
+            <a:srgbClr val="F2F2F2"/>
+          </a:solidFill>
+          <a:ln w="6350">
+            <a:solidFill>
+              <a:srgbClr val="E4E4E4"/>
+            </a:solidFill>
+            <a:prstDash val="solid"/>
+          </a:ln>
+        </p:spPr>
+      </p:sp>
+      <p:sp>
+        <p:nvSpPr>
+          <p:cNvPr id="21" name="Text 19"/>
+          <p:cNvSpPr/>
+          <p:nvPr/>
+        </p:nvSpPr>
+        <p:spPr>
+          <a:xfrm>
+            <a:off x="5943600" y="1143000"/>
+            <a:ext cx="1234440" cy="201168"/>
+          </a:xfrm>
+          <a:prstGeom prst="rect">
+            <a:avLst/>
+          </a:prstGeom>
+          <a:noFill/>
+          <a:ln/>
+        </p:spPr>
+        <p:txBody>
+          <a:bodyPr wrap="square" lIns="0" tIns="0" rIns="0" bIns="0" rtlCol="0" anchor="ctr"/>
+          <a:lstStyle/>
+          <a:p>
+            <a:pPr indent="0" marL="0">
+              <a:buNone/>
+            </a:pPr>
+            <a:r>
+              <a:rPr lang="en-US" sz="700" b="1" spc="100" kern="0" dirty="0">
+                <a:solidFill>
+                  <a:srgbClr val="E05C5C"/>
+                </a:solidFill>
+                <a:latin typeface="Calibri" pitchFamily="34" charset="0"/>
+                <a:ea typeface="Calibri" pitchFamily="34" charset="-122"/>
+                <a:cs typeface="Calibri" pitchFamily="34" charset="-120"/>
+              </a:rPr>
+              <a:t>SIN CONTEXTO</a:t>
+            </a:r>
+            <a:endParaRPr lang="en-US" sz="700" dirty="0"/>
+          </a:p>
+        </p:txBody>
+      </p:sp>
+      <p:sp>
+        <p:nvSpPr>
+          <p:cNvPr id="22" name="Shape 20"/>
+          <p:cNvSpPr/>
+          <p:nvPr/>
+        </p:nvSpPr>
+        <p:spPr>
+          <a:xfrm>
+            <a:off x="5943600" y="1371600"/>
+            <a:ext cx="2651760" cy="1005840"/>
+          </a:xfrm>
+          <a:prstGeom prst="rect">
+            <a:avLst/>
+          </a:prstGeom>
+          <a:solidFill>
+            <a:srgbClr val="FFF5F5"/>
+          </a:solidFill>
+          <a:ln w="6350">
+            <a:solidFill>
+              <a:srgbClr val="FFCDD2"/>
+            </a:solidFill>
+            <a:prstDash val="solid"/>
+          </a:ln>
+        </p:spPr>
+      </p:sp>
+      <p:sp>
+        <p:nvSpPr>
+          <p:cNvPr id="23" name="Text 21"/>
+          <p:cNvSpPr/>
+          <p:nvPr/>
+        </p:nvSpPr>
+        <p:spPr>
+          <a:xfrm>
+            <a:off x="5989320" y="1417320"/>
+            <a:ext cx="2560320" cy="914400"/>
+          </a:xfrm>
+          <a:prstGeom prst="rect">
+            <a:avLst/>
+          </a:prstGeom>
+          <a:noFill/>
+          <a:ln/>
+        </p:spPr>
+        <p:txBody>
+          <a:bodyPr wrap="square" lIns="0" tIns="0" rIns="0" bIns="0" rtlCol="0" anchor="ctr"/>
+          <a:lstStyle/>
+          <a:p>
+            <a:pPr indent="0" marL="0">
+              <a:buNone/>
+            </a:pPr>
+            <a:r>
+              <a:rPr lang="en-US" sz="950" i="1" dirty="0">
+                <a:solidFill>
+                  <a:srgbClr val="8A3030"/>
+                </a:solidFill>
+                <a:latin typeface="Calibri" pitchFamily="34" charset="0"/>
+                <a:ea typeface="Calibri" pitchFamily="34" charset="-122"/>
+                <a:cs typeface="Calibri" pitchFamily="34" charset="-120"/>
+              </a:rPr>
+              <a:t>"Hazme un plan de clase sobre los sacramentos."</a:t>
+            </a:r>
+            <a:endParaRPr lang="en-US" sz="950" dirty="0"/>
+          </a:p>
+        </p:txBody>
+      </p:sp>
+      <p:sp>
+        <p:nvSpPr>
+          <p:cNvPr id="24" name="Text 22"/>
+          <p:cNvSpPr/>
+          <p:nvPr/>
+        </p:nvSpPr>
+        <p:spPr>
+          <a:xfrm>
+            <a:off x="5943600" y="2487168"/>
+            <a:ext cx="1371600" cy="201168"/>
+          </a:xfrm>
+          <a:prstGeom prst="rect">
+            <a:avLst/>
+          </a:prstGeom>
+          <a:noFill/>
+          <a:ln/>
+        </p:spPr>
+        <p:txBody>
+          <a:bodyPr wrap="square" lIns="0" tIns="0" rIns="0" bIns="0" rtlCol="0" anchor="ctr"/>
+          <a:lstStyle/>
+          <a:p>
+            <a:pPr indent="0" marL="0">
+              <a:buNone/>
+            </a:pPr>
+            <a:r>
+              <a:rPr lang="en-US" sz="700" b="1" spc="100" kern="0" dirty="0">
+                <a:solidFill>
+                  <a:srgbClr val="2DC653"/>
+                </a:solidFill>
+                <a:latin typeface="Calibri" pitchFamily="34" charset="0"/>
+                <a:ea typeface="Calibri" pitchFamily="34" charset="-122"/>
+                <a:cs typeface="Calibri" pitchFamily="34" charset="-120"/>
+              </a:rPr>
+              <a:t>CON CONTEXTO</a:t>
+            </a:r>
+            <a:endParaRPr lang="en-US" sz="700" dirty="0"/>
+          </a:p>
+        </p:txBody>
+      </p:sp>
+      <p:sp>
+        <p:nvSpPr>
+          <p:cNvPr id="25" name="Shape 23"/>
+          <p:cNvSpPr/>
+          <p:nvPr/>
+        </p:nvSpPr>
+        <p:spPr>
+          <a:xfrm>
+            <a:off x="5943600" y="2706624"/>
+            <a:ext cx="2651760" cy="1920240"/>
+          </a:xfrm>
+          <a:prstGeom prst="rect">
+            <a:avLst/>
+          </a:prstGeom>
+          <a:solidFill>
+            <a:srgbClr val="F0FFF4"/>
+          </a:solidFill>
+          <a:ln w="6350">
+            <a:solidFill>
+              <a:srgbClr val="B8DECA"/>
+            </a:solidFill>
+            <a:prstDash val="solid"/>
+          </a:ln>
+        </p:spPr>
+      </p:sp>
+      <p:sp>
+        <p:nvSpPr>
+          <p:cNvPr id="26" name="Text 24"/>
+          <p:cNvSpPr/>
+          <p:nvPr/>
+        </p:nvSpPr>
+        <p:spPr>
+          <a:xfrm>
+            <a:off x="5989320" y="2752344"/>
+            <a:ext cx="2560320" cy="1828800"/>
+          </a:xfrm>
+          <a:prstGeom prst="rect">
+            <a:avLst/>
+          </a:prstGeom>
+          <a:noFill/>
+          <a:ln/>
+        </p:spPr>
+        <p:txBody>
+          <a:bodyPr wrap="square" lIns="0" tIns="0" rIns="0" bIns="0" rtlCol="0" anchor="t"/>
+          <a:lstStyle/>
+          <a:p>
+            <a:pPr indent="0" marL="0">
+              <a:buNone/>
+            </a:pPr>
+            <a:r>
+              <a:rPr lang="en-US" sz="850" dirty="0">
+                <a:solidFill>
+                  <a:srgbClr val="1A3528"/>
+                </a:solidFill>
+                <a:latin typeface="Calibri" pitchFamily="34" charset="0"/>
+                <a:ea typeface="Calibri" pitchFamily="34" charset="-122"/>
+                <a:cs typeface="Calibri" pitchFamily="34" charset="-120"/>
+              </a:rPr>
+              <a:t>"Actúa como asistente de religión K-12. Estoy planificando Sacramentos en 9no. Objetivo: que el estudiante los viva como encuentro, no como ritual (CIC 1084). Estudiantes de 14-15 años, buscan autenticidad. Genera un hook de 10 min."</a:t>
+            </a:r>
+            <a:endParaRPr lang="en-US" sz="850" dirty="0"/>
+          </a:p>
+        </p:txBody>
+      </p:sp>
+      <p:sp>
+        <p:nvSpPr>
+          <p:cNvPr id="27" name="Text 25"/>
+          <p:cNvSpPr/>
+          <p:nvPr/>
+        </p:nvSpPr>
+        <p:spPr>
+          <a:xfrm>
+            <a:off x="457200" y="4892040"/>
+            <a:ext cx="1828800" cy="201168"/>
+          </a:xfrm>
+          <a:prstGeom prst="rect">
+            <a:avLst/>
+          </a:prstGeom>
+          <a:noFill/>
+          <a:ln/>
+        </p:spPr>
+        <p:txBody>
+          <a:bodyPr wrap="square" lIns="0" tIns="0" rIns="0" bIns="0" rtlCol="0" anchor="ctr"/>
+          <a:lstStyle/>
+          <a:p>
+            <a:pPr indent="0" marL="0">
+              <a:buNone/>
+            </a:pPr>
+            <a:r>
+              <a:rPr lang="en-US" sz="800" dirty="0">
+                <a:solidFill>
+                  <a:srgbClr val="00B4D8"/>
+                </a:solidFill>
+                <a:latin typeface="Trebuchet MS" pitchFamily="34" charset="0"/>
+                <a:ea typeface="Trebuchet MS" pitchFamily="34" charset="-122"/>
+                <a:cs typeface="Trebuchet MS" pitchFamily="34" charset="-120"/>
+              </a:rPr>
+              <a:t>ETB.education</a:t>
+            </a:r>
+            <a:endParaRPr lang="en-US" sz="800" dirty="0"/>
+          </a:p>
+        </p:txBody>
+      </p:sp>
+    </p:spTree>
+  </p:cSld>
+  <p:clrMapOvr>
+    <a:masterClrMapping/>
+  </p:clrMapOvr>
+</p:sld>
+</file>
+
+<file path=ppt/slides/slide5.xml><?xml version="1.0" encoding="utf-8"?>
+<p:sld xmlns:a="http://schemas.openxmlformats.org/drawingml/2006/main" xmlns:r="http://schemas.openxmlformats.org/officeDocument/2006/relationships" xmlns:p="http://schemas.openxmlformats.org/presentationml/2006/main">
+  <p:cSld name="Slide 5">
+    <p:bg>
+      <p:bgPr>
+        <a:solidFill>
+          <a:srgbClr val="FFFFFF"/>
+        </a:solidFill>
+      </p:bgPr>
+    </p:bg>
+    <p:spTree>
+      <p:nvGrpSpPr>
+        <p:cNvPr id="1" name=""/>
+        <p:cNvGrpSpPr/>
+        <p:nvPr/>
+      </p:nvGrpSpPr>
+      <p:grpSpPr>
+        <a:xfrm>
+          <a:off x="0" y="0"/>
+          <a:ext cx="0" cy="0"/>
+          <a:chOff x="0" y="0"/>
+          <a:chExt cx="0" cy="0"/>
+        </a:xfrm>
+      </p:grpSpPr>
+      <p:sp>
+        <p:nvSpPr>
+          <p:cNvPr id="2" name="Shape 0"/>
+          <p:cNvSpPr/>
+          <p:nvPr/>
+        </p:nvSpPr>
+        <p:spPr>
+          <a:xfrm>
+            <a:off x="0" y="0"/>
+            <a:ext cx="9144000" cy="64008"/>
+          </a:xfrm>
+          <a:prstGeom prst="rect">
+            <a:avLst/>
+          </a:prstGeom>
+          <a:solidFill>
+            <a:srgbClr val="00B4D8"/>
+          </a:solidFill>
+          <a:ln w="12700">
+            <a:solidFill>
+              <a:srgbClr val="00B4D8"/>
+            </a:solidFill>
+            <a:prstDash val="solid"/>
+          </a:ln>
+        </p:spPr>
+      </p:sp>
+      <p:sp>
+        <p:nvSpPr>
+          <p:cNvPr id="3" name="Text 1"/>
+          <p:cNvSpPr/>
+          <p:nvPr/>
+        </p:nvSpPr>
+        <p:spPr>
+          <a:xfrm>
+            <a:off x="457200" y="182880"/>
+            <a:ext cx="8229600" cy="256032"/>
+          </a:xfrm>
+          <a:prstGeom prst="rect">
+            <a:avLst/>
+          </a:prstGeom>
+          <a:noFill/>
+          <a:ln/>
+        </p:spPr>
+        <p:txBody>
+          <a:bodyPr wrap="square" lIns="0" tIns="0" rIns="0" bIns="0" rtlCol="0" anchor="ctr"/>
+          <a:lstStyle/>
+          <a:p>
+            <a:pPr indent="0" marL="0">
+              <a:buNone/>
+            </a:pPr>
+            <a:r>
+              <a:rPr lang="en-US" sz="850" spc="250" kern="0" dirty="0">
+                <a:solidFill>
+                  <a:srgbClr val="00B4D8"/>
+                </a:solidFill>
+                <a:latin typeface="Calibri" pitchFamily="34" charset="0"/>
+                <a:ea typeface="Calibri" pitchFamily="34" charset="-122"/>
+                <a:cs typeface="Calibri" pitchFamily="34" charset="-120"/>
+              </a:rPr>
               <a:t>HERRAMIENTAS DE GENERACIÓN</a:t>
             </a:r>
             <a:endParaRPr lang="en-US" sz="850" dirty="0"/>
@@ -5037,9 +6001,9 @@
 </p:sld>
 </file>
 
-<file path=ppt/slides/slide5.xml><?xml version="1.0" encoding="utf-8"?>
+<file path=ppt/slides/slide6.xml><?xml version="1.0" encoding="utf-8"?>
 <p:sld xmlns:a="http://schemas.openxmlformats.org/drawingml/2006/main" xmlns:r="http://schemas.openxmlformats.org/officeDocument/2006/relationships" xmlns:p="http://schemas.openxmlformats.org/presentationml/2006/main">
-  <p:cSld name="Slide 5">
+  <p:cSld name="Slide 6">
     <p:bg>
       <p:bgPr>
         <a:solidFill>

</xml_diff>

<commit_message>
Add: QR slide with all workflow tools
</commit_message>
<xml_diff>
--- a/ETB-IA-Religion-Video.pptx
+++ b/ETB-IA-Religion-Video.pptx
@@ -11,9 +11,10 @@
     <p:sldId id="259" r:id="rId5"/>
     <p:sldId id="260" r:id="rId6"/>
     <p:sldId id="261" r:id="rId7"/>
+    <p:sldId id="262" r:id="rId8"/>
   </p:sldIdLst>
   <p:notesMasterIdLst>
-    <p:notesMasterId r:id="rId8"/>
+    <p:notesMasterId r:id="rId9"/>
   </p:notesMasterIdLst>
   <p:sldSz cx="9144000" cy="5143500"/>
   <p:notesSz cx="5143500" cy="9144000"/>
@@ -983,6 +984,103 @@
           <a:p>
             <a:r>
               <a:rPr lang="en-US" dirty="0"/>
+              <a:t>NOTAS DEL PRESENTADOR — SLIDE QR · HERRAMIENTAS
+Esta slide se queda en pantalla mientras hacen preguntas o mientras los maestros sacan sus teléfonos.
+Antes de cerrar — aquí tienen acceso directo a todo lo que vimos hoy. Seis códigos QR:
+NotebookLM — gratuito con cuenta de Google. Suban el PDF de sus estándares esta semana.
+Magisterium AI — tiene versión gratuita con límite de consultas. Suficiente para empezar.
+La plataforma editorial de su libro — ya la tienen. Solo que ahora la van a usar diferente: como generador del primer prompt.
+MagicSchool AI — muchos de ustedes ya la conocen. Úsenla con el prompt que construye el workflow.
+CopilotERE — el asistente personalizado para maestros de religión. Tiene los estándares cargados.
+Y el repo de ETB — ahí están el workflow completo, el diagrama, y el prompt template descargable.
+[Dejar la slide en pantalla · dar tiempo para escanear]</a:t>
+            </a:r>
+            <a:endParaRPr lang="en-US" dirty="0"/>
+          </a:p>
+        </p:txBody>
+      </p:sp>
+      <p:sp>
+        <p:nvSpPr>
+          <p:cNvPr id="4" name="Slide Number Placeholder 3"/>
+          <p:cNvSpPr>
+            <a:spLocks noGrp="1"/>
+          </p:cNvSpPr>
+          <p:nvPr>
+            <p:ph type="sldNum" sz="quarter" idx="10"/>
+          </p:nvPr>
+        </p:nvSpPr>
+        <p:spPr/>
+        <p:txBody>
+          <a:bodyPr/>
+          <a:lstStyle/>
+          <a:p>
+            <a:fld id="{F7021451-1387-4CA6-816F-3879F97B5CBC}" type="slidenum">
+              <a:rPr lang="en-US"/>
+              <a:t>6</a:t>
+            </a:fld>
+            <a:endParaRPr lang="en-US"/>
+          </a:p>
+        </p:txBody>
+      </p:sp>
+    </p:spTree>
+    <p:extLst>
+      <p:ext uri="{BB962C8B-B14F-4D97-AF65-F5344CB8AC3E}">
+        <p14:creationId xmlns:p14="http://schemas.microsoft.com/office/powerpoint/2010/main" val="1024086991"/>
+      </p:ext>
+    </p:extLst>
+  </p:cSld>
+  <p:clrMapOvr>
+    <a:masterClrMapping/>
+  </p:clrMapOvr>
+</p:notes>
+</file>
+
+<file path=ppt/notesSlides/notesSlide7.xml><?xml version="1.0" encoding="utf-8"?>
+<p:notes xmlns:a="http://schemas.openxmlformats.org/drawingml/2006/main" xmlns:r="http://schemas.openxmlformats.org/officeDocument/2006/relationships" xmlns:p="http://schemas.openxmlformats.org/presentationml/2006/main">
+  <p:cSld>
+    <p:spTree>
+      <p:nvGrpSpPr>
+        <p:cNvPr id="1" name=""/>
+        <p:cNvGrpSpPr/>
+        <p:nvPr/>
+      </p:nvGrpSpPr>
+      <p:grpSpPr>
+        <a:xfrm>
+          <a:off x="0" y="0"/>
+          <a:ext cx="0" cy="0"/>
+          <a:chOff x="0" y="0"/>
+          <a:chExt cx="0" cy="0"/>
+        </a:xfrm>
+      </p:grpSpPr>
+      <p:sp>
+        <p:nvSpPr>
+          <p:cNvPr id="2" name="Slide Image Placeholder 1"/>
+          <p:cNvSpPr>
+            <a:spLocks noGrp="1" noRot="1" noChangeAspect="1"/>
+          </p:cNvSpPr>
+          <p:nvPr>
+            <p:ph type="sldImg"/>
+          </p:nvPr>
+        </p:nvSpPr>
+        <p:spPr/>
+      </p:sp>
+      <p:sp>
+        <p:nvSpPr>
+          <p:cNvPr id="3" name="Notes Placeholder 2"/>
+          <p:cNvSpPr>
+            <a:spLocks noGrp="1"/>
+          </p:cNvSpPr>
+          <p:nvPr>
+            <p:ph type="body" idx="1"/>
+          </p:nvPr>
+        </p:nvSpPr>
+        <p:spPr/>
+        <p:txBody>
+          <a:bodyPr/>
+          <a:lstStyle/>
+          <a:p>
+            <a:r>
+              <a:rPr lang="en-US" dirty="0"/>
               <a:t>NOTAS DEL PRESENTADOR — SLIDE 5 · CIERRE
 Resumamos en 60 segundos lo que vimos hoy.
 El workflow empieza en el libro — el recurso que ya tienen en mano. Desde ahí generamos el primer prompt para NotebookLM, donde conversamos con el documento de estándares. Luego vamos a Magisterium para validar las fuentes doctrinales, y esos outputs los añadimos al notebook. Con todo cargado, le pedimos el brief — y con solo el brief activo, NotebookLM nos genera el prompt listo para CopilotERE o MagicSchool. Y el resultado es una experiencia de aprendizaje fundamentada en el estándar, anclada en la doctrina, y diseñada para tus estudiantes reales.
@@ -1015,7 +1113,7 @@
           <a:p>
             <a:fld id="{F7021451-1387-4CA6-816F-3879F97B5CBC}" type="slidenum">
               <a:rPr lang="en-US"/>
-              <a:t>6</a:t>
+              <a:t>7</a:t>
             </a:fld>
             <a:endParaRPr lang="en-US"/>
           </a:p>
@@ -6004,6 +6102,1117 @@
 <file path=ppt/slides/slide6.xml><?xml version="1.0" encoding="utf-8"?>
 <p:sld xmlns:a="http://schemas.openxmlformats.org/drawingml/2006/main" xmlns:r="http://schemas.openxmlformats.org/officeDocument/2006/relationships" xmlns:p="http://schemas.openxmlformats.org/presentationml/2006/main">
   <p:cSld name="Slide 6">
+    <p:bg>
+      <p:bgPr>
+        <a:solidFill>
+          <a:srgbClr val="0D0D0D"/>
+        </a:solidFill>
+      </p:bgPr>
+    </p:bg>
+    <p:spTree>
+      <p:nvGrpSpPr>
+        <p:cNvPr id="1" name=""/>
+        <p:cNvGrpSpPr/>
+        <p:nvPr/>
+      </p:nvGrpSpPr>
+      <p:grpSpPr>
+        <a:xfrm>
+          <a:off x="0" y="0"/>
+          <a:ext cx="0" cy="0"/>
+          <a:chOff x="0" y="0"/>
+          <a:chExt cx="0" cy="0"/>
+        </a:xfrm>
+      </p:grpSpPr>
+      <p:sp>
+        <p:nvSpPr>
+          <p:cNvPr id="2" name="Shape 0"/>
+          <p:cNvSpPr/>
+          <p:nvPr/>
+        </p:nvSpPr>
+        <p:spPr>
+          <a:xfrm>
+            <a:off x="0" y="0"/>
+            <a:ext cx="9144000" cy="54864"/>
+          </a:xfrm>
+          <a:prstGeom prst="rect">
+            <a:avLst/>
+          </a:prstGeom>
+          <a:solidFill>
+            <a:srgbClr val="00B4D8"/>
+          </a:solidFill>
+          <a:ln w="12700">
+            <a:solidFill>
+              <a:srgbClr val="00B4D8"/>
+            </a:solidFill>
+            <a:prstDash val="solid"/>
+          </a:ln>
+        </p:spPr>
+      </p:sp>
+      <p:sp>
+        <p:nvSpPr>
+          <p:cNvPr id="3" name="Text 1"/>
+          <p:cNvSpPr/>
+          <p:nvPr/>
+        </p:nvSpPr>
+        <p:spPr>
+          <a:xfrm>
+            <a:off x="457200" y="137160"/>
+            <a:ext cx="8229600" cy="237744"/>
+          </a:xfrm>
+          <a:prstGeom prst="rect">
+            <a:avLst/>
+          </a:prstGeom>
+          <a:noFill/>
+          <a:ln/>
+        </p:spPr>
+        <p:txBody>
+          <a:bodyPr wrap="square" lIns="0" tIns="0" rIns="0" bIns="0" rtlCol="0" anchor="ctr"/>
+          <a:lstStyle/>
+          <a:p>
+            <a:pPr indent="0" marL="0">
+              <a:buNone/>
+            </a:pPr>
+            <a:r>
+              <a:rPr lang="en-US" sz="800" spc="250" kern="0" dirty="0">
+                <a:solidFill>
+                  <a:srgbClr val="00B4D8"/>
+                </a:solidFill>
+                <a:latin typeface="Calibri" pitchFamily="34" charset="0"/>
+                <a:ea typeface="Calibri" pitchFamily="34" charset="-122"/>
+                <a:cs typeface="Calibri" pitchFamily="34" charset="-120"/>
+              </a:rPr>
+              <a:t>HERRAMIENTAS Y RECURSOS DEL WORKFLOW</a:t>
+            </a:r>
+            <a:endParaRPr lang="en-US" sz="800" dirty="0"/>
+          </a:p>
+        </p:txBody>
+      </p:sp>
+      <p:sp>
+        <p:nvSpPr>
+          <p:cNvPr id="4" name="Text 2"/>
+          <p:cNvSpPr/>
+          <p:nvPr/>
+        </p:nvSpPr>
+        <p:spPr>
+          <a:xfrm>
+            <a:off x="457200" y="384048"/>
+            <a:ext cx="8229600" cy="438912"/>
+          </a:xfrm>
+          <a:prstGeom prst="rect">
+            <a:avLst/>
+          </a:prstGeom>
+          <a:noFill/>
+          <a:ln/>
+        </p:spPr>
+        <p:txBody>
+          <a:bodyPr wrap="square" lIns="0" tIns="0" rIns="0" bIns="0" rtlCol="0" anchor="ctr"/>
+          <a:lstStyle/>
+          <a:p>
+            <a:pPr indent="0" marL="0">
+              <a:buNone/>
+            </a:pPr>
+            <a:r>
+              <a:rPr lang="en-US" sz="2400" b="1" dirty="0">
+                <a:solidFill>
+                  <a:srgbClr val="FFFFFF"/>
+                </a:solidFill>
+                <a:latin typeface="Trebuchet MS" pitchFamily="34" charset="0"/>
+                <a:ea typeface="Trebuchet MS" pitchFamily="34" charset="-122"/>
+                <a:cs typeface="Trebuchet MS" pitchFamily="34" charset="-120"/>
+              </a:rPr>
+              <a:t>Escanea · Accede · Planifica</a:t>
+            </a:r>
+            <a:endParaRPr lang="en-US" sz="2400" dirty="0"/>
+          </a:p>
+        </p:txBody>
+      </p:sp>
+      <p:sp>
+        <p:nvSpPr>
+          <p:cNvPr id="5" name="Shape 3"/>
+          <p:cNvSpPr/>
+          <p:nvPr/>
+        </p:nvSpPr>
+        <p:spPr>
+          <a:xfrm>
+            <a:off x="411480" y="960120"/>
+            <a:ext cx="2651760" cy="1783080"/>
+          </a:xfrm>
+          <a:prstGeom prst="rect">
+            <a:avLst/>
+          </a:prstGeom>
+          <a:solidFill>
+            <a:srgbClr val="161616"/>
+          </a:solidFill>
+          <a:ln w="12700">
+            <a:solidFill>
+              <a:srgbClr val="00B4D8"/>
+            </a:solidFill>
+            <a:prstDash val="solid"/>
+          </a:ln>
+        </p:spPr>
+      </p:sp>
+      <p:sp>
+        <p:nvSpPr>
+          <p:cNvPr id="6" name="Shape 4"/>
+          <p:cNvSpPr/>
+          <p:nvPr/>
+        </p:nvSpPr>
+        <p:spPr>
+          <a:xfrm>
+            <a:off x="411480" y="960120"/>
+            <a:ext cx="45720" cy="1783080"/>
+          </a:xfrm>
+          <a:prstGeom prst="rect">
+            <a:avLst/>
+          </a:prstGeom>
+          <a:solidFill>
+            <a:srgbClr val="00B4D8"/>
+          </a:solidFill>
+          <a:ln w="12700">
+            <a:solidFill>
+              <a:srgbClr val="00B4D8"/>
+            </a:solidFill>
+            <a:prstDash val="solid"/>
+          </a:ln>
+        </p:spPr>
+      </p:sp>
+      <p:pic>
+        <p:nvPicPr>
+          <p:cNvPr id="7" name="Image 0" descr="preencoded.png">    </p:cNvPr>
+          <p:cNvPicPr>
+            <a:picLocks noChangeAspect="1"/>
+          </p:cNvPicPr>
+          <p:nvPr/>
+        </p:nvPicPr>
+        <p:blipFill>
+          <a:blip r:embed="rId1"/>
+          <a:stretch>
+            <a:fillRect/>
+          </a:stretch>
+        </p:blipFill>
+        <p:spPr>
+          <a:xfrm>
+            <a:off x="548640" y="1216152"/>
+            <a:ext cx="1188720" cy="1188720"/>
+          </a:xfrm>
+          <a:prstGeom prst="rect">
+            <a:avLst/>
+          </a:prstGeom>
+        </p:spPr>
+      </p:pic>
+      <p:sp>
+        <p:nvSpPr>
+          <p:cNvPr id="8" name="Text 5"/>
+          <p:cNvSpPr/>
+          <p:nvPr/>
+        </p:nvSpPr>
+        <p:spPr>
+          <a:xfrm>
+            <a:off x="1828800" y="1234440"/>
+            <a:ext cx="1143000" cy="347472"/>
+          </a:xfrm>
+          <a:prstGeom prst="rect">
+            <a:avLst/>
+          </a:prstGeom>
+          <a:noFill/>
+          <a:ln/>
+        </p:spPr>
+        <p:txBody>
+          <a:bodyPr wrap="square" lIns="0" tIns="0" rIns="0" bIns="0" rtlCol="0" anchor="ctr"/>
+          <a:lstStyle/>
+          <a:p>
+            <a:pPr indent="0" marL="0">
+              <a:buNone/>
+            </a:pPr>
+            <a:r>
+              <a:rPr lang="en-US" sz="1200" b="1" dirty="0">
+                <a:solidFill>
+                  <a:srgbClr val="FFFFFF"/>
+                </a:solidFill>
+                <a:latin typeface="Trebuchet MS" pitchFamily="34" charset="0"/>
+                <a:ea typeface="Trebuchet MS" pitchFamily="34" charset="-122"/>
+                <a:cs typeface="Trebuchet MS" pitchFamily="34" charset="-120"/>
+              </a:rPr>
+              <a:t>NotebookLM</a:t>
+            </a:r>
+            <a:endParaRPr lang="en-US" sz="1200" dirty="0"/>
+          </a:p>
+        </p:txBody>
+      </p:sp>
+      <p:sp>
+        <p:nvSpPr>
+          <p:cNvPr id="9" name="Text 6"/>
+          <p:cNvSpPr/>
+          <p:nvPr/>
+        </p:nvSpPr>
+        <p:spPr>
+          <a:xfrm>
+            <a:off x="1828800" y="1600200"/>
+            <a:ext cx="1143000" cy="502920"/>
+          </a:xfrm>
+          <a:prstGeom prst="rect">
+            <a:avLst/>
+          </a:prstGeom>
+          <a:noFill/>
+          <a:ln/>
+        </p:spPr>
+        <p:txBody>
+          <a:bodyPr wrap="square" lIns="0" tIns="0" rIns="0" bIns="0" rtlCol="0" anchor="ctr"/>
+          <a:lstStyle/>
+          <a:p>
+            <a:pPr indent="0" marL="0">
+              <a:buNone/>
+            </a:pPr>
+            <a:r>
+              <a:rPr lang="en-US" sz="800" i="1" dirty="0">
+                <a:solidFill>
+                  <a:srgbClr val="00B4D8"/>
+                </a:solidFill>
+                <a:latin typeface="Calibri" pitchFamily="34" charset="0"/>
+                <a:ea typeface="Calibri" pitchFamily="34" charset="-122"/>
+                <a:cs typeface="Calibri" pitchFamily="34" charset="-120"/>
+              </a:rPr>
+              <a:t>notebooklm.google.com</a:t>
+            </a:r>
+            <a:endParaRPr lang="en-US" sz="800" dirty="0"/>
+          </a:p>
+        </p:txBody>
+      </p:sp>
+      <p:sp>
+        <p:nvSpPr>
+          <p:cNvPr id="10" name="Shape 7"/>
+          <p:cNvSpPr/>
+          <p:nvPr/>
+        </p:nvSpPr>
+        <p:spPr>
+          <a:xfrm>
+            <a:off x="3246120" y="960120"/>
+            <a:ext cx="2651760" cy="1783080"/>
+          </a:xfrm>
+          <a:prstGeom prst="rect">
+            <a:avLst/>
+          </a:prstGeom>
+          <a:solidFill>
+            <a:srgbClr val="161616"/>
+          </a:solidFill>
+          <a:ln w="12700">
+            <a:solidFill>
+              <a:srgbClr val="2DC653"/>
+            </a:solidFill>
+            <a:prstDash val="solid"/>
+          </a:ln>
+        </p:spPr>
+      </p:sp>
+      <p:sp>
+        <p:nvSpPr>
+          <p:cNvPr id="11" name="Shape 8"/>
+          <p:cNvSpPr/>
+          <p:nvPr/>
+        </p:nvSpPr>
+        <p:spPr>
+          <a:xfrm>
+            <a:off x="3246120" y="960120"/>
+            <a:ext cx="45720" cy="1783080"/>
+          </a:xfrm>
+          <a:prstGeom prst="rect">
+            <a:avLst/>
+          </a:prstGeom>
+          <a:solidFill>
+            <a:srgbClr val="2DC653"/>
+          </a:solidFill>
+          <a:ln w="12700">
+            <a:solidFill>
+              <a:srgbClr val="2DC653"/>
+            </a:solidFill>
+            <a:prstDash val="solid"/>
+          </a:ln>
+        </p:spPr>
+      </p:sp>
+      <p:pic>
+        <p:nvPicPr>
+          <p:cNvPr id="12" name="Image 1" descr="preencoded.png">    </p:cNvPr>
+          <p:cNvPicPr>
+            <a:picLocks noChangeAspect="1"/>
+          </p:cNvPicPr>
+          <p:nvPr/>
+        </p:nvPicPr>
+        <p:blipFill>
+          <a:blip r:embed="rId2"/>
+          <a:stretch>
+            <a:fillRect/>
+          </a:stretch>
+        </p:blipFill>
+        <p:spPr>
+          <a:xfrm>
+            <a:off x="3383280" y="1216152"/>
+            <a:ext cx="1188720" cy="1188720"/>
+          </a:xfrm>
+          <a:prstGeom prst="rect">
+            <a:avLst/>
+          </a:prstGeom>
+        </p:spPr>
+      </p:pic>
+      <p:sp>
+        <p:nvSpPr>
+          <p:cNvPr id="13" name="Text 9"/>
+          <p:cNvSpPr/>
+          <p:nvPr/>
+        </p:nvSpPr>
+        <p:spPr>
+          <a:xfrm>
+            <a:off x="4663440" y="1234440"/>
+            <a:ext cx="1143000" cy="347472"/>
+          </a:xfrm>
+          <a:prstGeom prst="rect">
+            <a:avLst/>
+          </a:prstGeom>
+          <a:noFill/>
+          <a:ln/>
+        </p:spPr>
+        <p:txBody>
+          <a:bodyPr wrap="square" lIns="0" tIns="0" rIns="0" bIns="0" rtlCol="0" anchor="ctr"/>
+          <a:lstStyle/>
+          <a:p>
+            <a:pPr indent="0" marL="0">
+              <a:buNone/>
+            </a:pPr>
+            <a:r>
+              <a:rPr lang="en-US" sz="1200" b="1" dirty="0">
+                <a:solidFill>
+                  <a:srgbClr val="FFFFFF"/>
+                </a:solidFill>
+                <a:latin typeface="Trebuchet MS" pitchFamily="34" charset="0"/>
+                <a:ea typeface="Trebuchet MS" pitchFamily="34" charset="-122"/>
+                <a:cs typeface="Trebuchet MS" pitchFamily="34" charset="-120"/>
+              </a:rPr>
+              <a:t>Magisterium AI</a:t>
+            </a:r>
+            <a:endParaRPr lang="en-US" sz="1200" dirty="0"/>
+          </a:p>
+        </p:txBody>
+      </p:sp>
+      <p:sp>
+        <p:nvSpPr>
+          <p:cNvPr id="14" name="Text 10"/>
+          <p:cNvSpPr/>
+          <p:nvPr/>
+        </p:nvSpPr>
+        <p:spPr>
+          <a:xfrm>
+            <a:off x="4663440" y="1600200"/>
+            <a:ext cx="1143000" cy="502920"/>
+          </a:xfrm>
+          <a:prstGeom prst="rect">
+            <a:avLst/>
+          </a:prstGeom>
+          <a:noFill/>
+          <a:ln/>
+        </p:spPr>
+        <p:txBody>
+          <a:bodyPr wrap="square" lIns="0" tIns="0" rIns="0" bIns="0" rtlCol="0" anchor="ctr"/>
+          <a:lstStyle/>
+          <a:p>
+            <a:pPr indent="0" marL="0">
+              <a:buNone/>
+            </a:pPr>
+            <a:r>
+              <a:rPr lang="en-US" sz="800" i="1" dirty="0">
+                <a:solidFill>
+                  <a:srgbClr val="2DC653"/>
+                </a:solidFill>
+                <a:latin typeface="Calibri" pitchFamily="34" charset="0"/>
+                <a:ea typeface="Calibri" pitchFamily="34" charset="-122"/>
+                <a:cs typeface="Calibri" pitchFamily="34" charset="-120"/>
+              </a:rPr>
+              <a:t>magisteriumai.com</a:t>
+            </a:r>
+            <a:endParaRPr lang="en-US" sz="800" dirty="0"/>
+          </a:p>
+        </p:txBody>
+      </p:sp>
+      <p:sp>
+        <p:nvSpPr>
+          <p:cNvPr id="15" name="Shape 11"/>
+          <p:cNvSpPr/>
+          <p:nvPr/>
+        </p:nvSpPr>
+        <p:spPr>
+          <a:xfrm>
+            <a:off x="6080760" y="960120"/>
+            <a:ext cx="2651760" cy="1783080"/>
+          </a:xfrm>
+          <a:prstGeom prst="rect">
+            <a:avLst/>
+          </a:prstGeom>
+          <a:solidFill>
+            <a:srgbClr val="161616"/>
+          </a:solidFill>
+          <a:ln w="12700">
+            <a:solidFill>
+              <a:srgbClr val="F4A01C"/>
+            </a:solidFill>
+            <a:prstDash val="solid"/>
+          </a:ln>
+        </p:spPr>
+      </p:sp>
+      <p:sp>
+        <p:nvSpPr>
+          <p:cNvPr id="16" name="Shape 12"/>
+          <p:cNvSpPr/>
+          <p:nvPr/>
+        </p:nvSpPr>
+        <p:spPr>
+          <a:xfrm>
+            <a:off x="6080760" y="960120"/>
+            <a:ext cx="45720" cy="1783080"/>
+          </a:xfrm>
+          <a:prstGeom prst="rect">
+            <a:avLst/>
+          </a:prstGeom>
+          <a:solidFill>
+            <a:srgbClr val="F4A01C"/>
+          </a:solidFill>
+          <a:ln w="12700">
+            <a:solidFill>
+              <a:srgbClr val="F4A01C"/>
+            </a:solidFill>
+            <a:prstDash val="solid"/>
+          </a:ln>
+        </p:spPr>
+      </p:sp>
+      <p:pic>
+        <p:nvPicPr>
+          <p:cNvPr id="17" name="Image 2" descr="preencoded.png">    </p:cNvPr>
+          <p:cNvPicPr>
+            <a:picLocks noChangeAspect="1"/>
+          </p:cNvPicPr>
+          <p:nvPr/>
+        </p:nvPicPr>
+        <p:blipFill>
+          <a:blip r:embed="rId3"/>
+          <a:stretch>
+            <a:fillRect/>
+          </a:stretch>
+        </p:blipFill>
+        <p:spPr>
+          <a:xfrm>
+            <a:off x="6217920" y="1216152"/>
+            <a:ext cx="1188720" cy="1188720"/>
+          </a:xfrm>
+          <a:prstGeom prst="rect">
+            <a:avLst/>
+          </a:prstGeom>
+        </p:spPr>
+      </p:pic>
+      <p:sp>
+        <p:nvSpPr>
+          <p:cNvPr id="18" name="Text 13"/>
+          <p:cNvSpPr/>
+          <p:nvPr/>
+        </p:nvSpPr>
+        <p:spPr>
+          <a:xfrm>
+            <a:off x="7498080" y="1234440"/>
+            <a:ext cx="1143000" cy="347472"/>
+          </a:xfrm>
+          <a:prstGeom prst="rect">
+            <a:avLst/>
+          </a:prstGeom>
+          <a:noFill/>
+          <a:ln/>
+        </p:spPr>
+        <p:txBody>
+          <a:bodyPr wrap="square" lIns="0" tIns="0" rIns="0" bIns="0" rtlCol="0" anchor="ctr"/>
+          <a:lstStyle/>
+          <a:p>
+            <a:pPr indent="0" marL="0">
+              <a:buNone/>
+            </a:pPr>
+            <a:r>
+              <a:rPr lang="en-US" sz="1200" b="1" dirty="0">
+                <a:solidFill>
+                  <a:srgbClr val="FFFFFF"/>
+                </a:solidFill>
+                <a:latin typeface="Trebuchet MS" pitchFamily="34" charset="0"/>
+                <a:ea typeface="Trebuchet MS" pitchFamily="34" charset="-122"/>
+                <a:cs typeface="Trebuchet MS" pitchFamily="34" charset="-120"/>
+              </a:rPr>
+              <a:t>Plataforma Editorial</a:t>
+            </a:r>
+            <a:endParaRPr lang="en-US" sz="1200" dirty="0"/>
+          </a:p>
+        </p:txBody>
+      </p:sp>
+      <p:sp>
+        <p:nvSpPr>
+          <p:cNvPr id="19" name="Text 14"/>
+          <p:cNvSpPr/>
+          <p:nvPr/>
+        </p:nvSpPr>
+        <p:spPr>
+          <a:xfrm>
+            <a:off x="7498080" y="1600200"/>
+            <a:ext cx="1143000" cy="502920"/>
+          </a:xfrm>
+          <a:prstGeom prst="rect">
+            <a:avLst/>
+          </a:prstGeom>
+          <a:noFill/>
+          <a:ln/>
+        </p:spPr>
+        <p:txBody>
+          <a:bodyPr wrap="square" lIns="0" tIns="0" rIns="0" bIns="0" rtlCol="0" anchor="ctr"/>
+          <a:lstStyle/>
+          <a:p>
+            <a:pPr indent="0" marL="0">
+              <a:buNone/>
+            </a:pPr>
+            <a:r>
+              <a:rPr lang="en-US" sz="800" i="1" dirty="0">
+                <a:solidFill>
+                  <a:srgbClr val="F4A01C"/>
+                </a:solidFill>
+                <a:latin typeface="Calibri" pitchFamily="34" charset="0"/>
+                <a:ea typeface="Calibri" pitchFamily="34" charset="-122"/>
+                <a:cs typeface="Calibri" pitchFamily="34" charset="-120"/>
+              </a:rPr>
+              <a:t>edicionessm.com</a:t>
+            </a:r>
+            <a:endParaRPr lang="en-US" sz="800" dirty="0"/>
+          </a:p>
+        </p:txBody>
+      </p:sp>
+      <p:sp>
+        <p:nvSpPr>
+          <p:cNvPr id="20" name="Shape 15"/>
+          <p:cNvSpPr/>
+          <p:nvPr/>
+        </p:nvSpPr>
+        <p:spPr>
+          <a:xfrm>
+            <a:off x="411480" y="2907792"/>
+            <a:ext cx="2651760" cy="1783080"/>
+          </a:xfrm>
+          <a:prstGeom prst="rect">
+            <a:avLst/>
+          </a:prstGeom>
+          <a:solidFill>
+            <a:srgbClr val="161616"/>
+          </a:solidFill>
+          <a:ln w="12700">
+            <a:solidFill>
+              <a:srgbClr val="7B5EA7"/>
+            </a:solidFill>
+            <a:prstDash val="solid"/>
+          </a:ln>
+        </p:spPr>
+      </p:sp>
+      <p:sp>
+        <p:nvSpPr>
+          <p:cNvPr id="21" name="Shape 16"/>
+          <p:cNvSpPr/>
+          <p:nvPr/>
+        </p:nvSpPr>
+        <p:spPr>
+          <a:xfrm>
+            <a:off x="411480" y="2907792"/>
+            <a:ext cx="45720" cy="1783080"/>
+          </a:xfrm>
+          <a:prstGeom prst="rect">
+            <a:avLst/>
+          </a:prstGeom>
+          <a:solidFill>
+            <a:srgbClr val="7B5EA7"/>
+          </a:solidFill>
+          <a:ln w="12700">
+            <a:solidFill>
+              <a:srgbClr val="7B5EA7"/>
+            </a:solidFill>
+            <a:prstDash val="solid"/>
+          </a:ln>
+        </p:spPr>
+      </p:sp>
+      <p:pic>
+        <p:nvPicPr>
+          <p:cNvPr id="22" name="Image 3" descr="preencoded.png">    </p:cNvPr>
+          <p:cNvPicPr>
+            <a:picLocks noChangeAspect="1"/>
+          </p:cNvPicPr>
+          <p:nvPr/>
+        </p:nvPicPr>
+        <p:blipFill>
+          <a:blip r:embed="rId4"/>
+          <a:stretch>
+            <a:fillRect/>
+          </a:stretch>
+        </p:blipFill>
+        <p:spPr>
+          <a:xfrm>
+            <a:off x="548640" y="3163824"/>
+            <a:ext cx="1188720" cy="1188720"/>
+          </a:xfrm>
+          <a:prstGeom prst="rect">
+            <a:avLst/>
+          </a:prstGeom>
+        </p:spPr>
+      </p:pic>
+      <p:sp>
+        <p:nvSpPr>
+          <p:cNvPr id="23" name="Text 17"/>
+          <p:cNvSpPr/>
+          <p:nvPr/>
+        </p:nvSpPr>
+        <p:spPr>
+          <a:xfrm>
+            <a:off x="1828800" y="3182112"/>
+            <a:ext cx="1143000" cy="347472"/>
+          </a:xfrm>
+          <a:prstGeom prst="rect">
+            <a:avLst/>
+          </a:prstGeom>
+          <a:noFill/>
+          <a:ln/>
+        </p:spPr>
+        <p:txBody>
+          <a:bodyPr wrap="square" lIns="0" tIns="0" rIns="0" bIns="0" rtlCol="0" anchor="ctr"/>
+          <a:lstStyle/>
+          <a:p>
+            <a:pPr indent="0" marL="0">
+              <a:buNone/>
+            </a:pPr>
+            <a:r>
+              <a:rPr lang="en-US" sz="1200" b="1" dirty="0">
+                <a:solidFill>
+                  <a:srgbClr val="FFFFFF"/>
+                </a:solidFill>
+                <a:latin typeface="Trebuchet MS" pitchFamily="34" charset="0"/>
+                <a:ea typeface="Trebuchet MS" pitchFamily="34" charset="-122"/>
+                <a:cs typeface="Trebuchet MS" pitchFamily="34" charset="-120"/>
+              </a:rPr>
+              <a:t>MagicSchool AI</a:t>
+            </a:r>
+            <a:endParaRPr lang="en-US" sz="1200" dirty="0"/>
+          </a:p>
+        </p:txBody>
+      </p:sp>
+      <p:sp>
+        <p:nvSpPr>
+          <p:cNvPr id="24" name="Text 18"/>
+          <p:cNvSpPr/>
+          <p:nvPr/>
+        </p:nvSpPr>
+        <p:spPr>
+          <a:xfrm>
+            <a:off x="1828800" y="3547872"/>
+            <a:ext cx="1143000" cy="502920"/>
+          </a:xfrm>
+          <a:prstGeom prst="rect">
+            <a:avLst/>
+          </a:prstGeom>
+          <a:noFill/>
+          <a:ln/>
+        </p:spPr>
+        <p:txBody>
+          <a:bodyPr wrap="square" lIns="0" tIns="0" rIns="0" bIns="0" rtlCol="0" anchor="ctr"/>
+          <a:lstStyle/>
+          <a:p>
+            <a:pPr indent="0" marL="0">
+              <a:buNone/>
+            </a:pPr>
+            <a:r>
+              <a:rPr lang="en-US" sz="800" i="1" dirty="0">
+                <a:solidFill>
+                  <a:srgbClr val="7B5EA7"/>
+                </a:solidFill>
+                <a:latin typeface="Calibri" pitchFamily="34" charset="0"/>
+                <a:ea typeface="Calibri" pitchFamily="34" charset="-122"/>
+                <a:cs typeface="Calibri" pitchFamily="34" charset="-120"/>
+              </a:rPr>
+              <a:t>magicschool.ai</a:t>
+            </a:r>
+            <a:endParaRPr lang="en-US" sz="800" dirty="0"/>
+          </a:p>
+        </p:txBody>
+      </p:sp>
+      <p:sp>
+        <p:nvSpPr>
+          <p:cNvPr id="25" name="Shape 19"/>
+          <p:cNvSpPr/>
+          <p:nvPr/>
+        </p:nvSpPr>
+        <p:spPr>
+          <a:xfrm>
+            <a:off x="3246120" y="2907792"/>
+            <a:ext cx="2651760" cy="1783080"/>
+          </a:xfrm>
+          <a:prstGeom prst="rect">
+            <a:avLst/>
+          </a:prstGeom>
+          <a:solidFill>
+            <a:srgbClr val="161616"/>
+          </a:solidFill>
+          <a:ln w="12700">
+            <a:solidFill>
+              <a:srgbClr val="0096B7"/>
+            </a:solidFill>
+            <a:prstDash val="solid"/>
+          </a:ln>
+        </p:spPr>
+      </p:sp>
+      <p:sp>
+        <p:nvSpPr>
+          <p:cNvPr id="26" name="Shape 20"/>
+          <p:cNvSpPr/>
+          <p:nvPr/>
+        </p:nvSpPr>
+        <p:spPr>
+          <a:xfrm>
+            <a:off x="3246120" y="2907792"/>
+            <a:ext cx="45720" cy="1783080"/>
+          </a:xfrm>
+          <a:prstGeom prst="rect">
+            <a:avLst/>
+          </a:prstGeom>
+          <a:solidFill>
+            <a:srgbClr val="0096B7"/>
+          </a:solidFill>
+          <a:ln w="12700">
+            <a:solidFill>
+              <a:srgbClr val="0096B7"/>
+            </a:solidFill>
+            <a:prstDash val="solid"/>
+          </a:ln>
+        </p:spPr>
+      </p:sp>
+      <p:pic>
+        <p:nvPicPr>
+          <p:cNvPr id="27" name="Image 4" descr="preencoded.png">    </p:cNvPr>
+          <p:cNvPicPr>
+            <a:picLocks noChangeAspect="1"/>
+          </p:cNvPicPr>
+          <p:nvPr/>
+        </p:nvPicPr>
+        <p:blipFill>
+          <a:blip r:embed="rId5"/>
+          <a:stretch>
+            <a:fillRect/>
+          </a:stretch>
+        </p:blipFill>
+        <p:spPr>
+          <a:xfrm>
+            <a:off x="3383280" y="3163824"/>
+            <a:ext cx="1188720" cy="1188720"/>
+          </a:xfrm>
+          <a:prstGeom prst="rect">
+            <a:avLst/>
+          </a:prstGeom>
+        </p:spPr>
+      </p:pic>
+      <p:sp>
+        <p:nvSpPr>
+          <p:cNvPr id="28" name="Text 21"/>
+          <p:cNvSpPr/>
+          <p:nvPr/>
+        </p:nvSpPr>
+        <p:spPr>
+          <a:xfrm>
+            <a:off x="4663440" y="3182112"/>
+            <a:ext cx="1143000" cy="347472"/>
+          </a:xfrm>
+          <a:prstGeom prst="rect">
+            <a:avLst/>
+          </a:prstGeom>
+          <a:noFill/>
+          <a:ln/>
+        </p:spPr>
+        <p:txBody>
+          <a:bodyPr wrap="square" lIns="0" tIns="0" rIns="0" bIns="0" rtlCol="0" anchor="ctr"/>
+          <a:lstStyle/>
+          <a:p>
+            <a:pPr indent="0" marL="0">
+              <a:buNone/>
+            </a:pPr>
+            <a:r>
+              <a:rPr lang="en-US" sz="1200" b="1" dirty="0">
+                <a:solidFill>
+                  <a:srgbClr val="FFFFFF"/>
+                </a:solidFill>
+                <a:latin typeface="Trebuchet MS" pitchFamily="34" charset="0"/>
+                <a:ea typeface="Trebuchet MS" pitchFamily="34" charset="-122"/>
+                <a:cs typeface="Trebuchet MS" pitchFamily="34" charset="-120"/>
+              </a:rPr>
+              <a:t>CopilotERE</a:t>
+            </a:r>
+            <a:endParaRPr lang="en-US" sz="1200" dirty="0"/>
+          </a:p>
+        </p:txBody>
+      </p:sp>
+      <p:sp>
+        <p:nvSpPr>
+          <p:cNvPr id="29" name="Text 22"/>
+          <p:cNvSpPr/>
+          <p:nvPr/>
+        </p:nvSpPr>
+        <p:spPr>
+          <a:xfrm>
+            <a:off x="4663440" y="3547872"/>
+            <a:ext cx="1143000" cy="502920"/>
+          </a:xfrm>
+          <a:prstGeom prst="rect">
+            <a:avLst/>
+          </a:prstGeom>
+          <a:noFill/>
+          <a:ln/>
+        </p:spPr>
+        <p:txBody>
+          <a:bodyPr wrap="square" lIns="0" tIns="0" rIns="0" bIns="0" rtlCol="0" anchor="ctr"/>
+          <a:lstStyle/>
+          <a:p>
+            <a:pPr indent="0" marL="0">
+              <a:buNone/>
+            </a:pPr>
+            <a:r>
+              <a:rPr lang="en-US" sz="800" i="1" dirty="0">
+                <a:solidFill>
+                  <a:srgbClr val="0096B7"/>
+                </a:solidFill>
+                <a:latin typeface="Calibri" pitchFamily="34" charset="0"/>
+                <a:ea typeface="Calibri" pitchFamily="34" charset="-122"/>
+                <a:cs typeface="Calibri" pitchFamily="34" charset="-120"/>
+              </a:rPr>
+              <a:t>chatgpt.com/g/g-NPtdk5rJ0</a:t>
+            </a:r>
+            <a:endParaRPr lang="en-US" sz="800" dirty="0"/>
+          </a:p>
+        </p:txBody>
+      </p:sp>
+      <p:sp>
+        <p:nvSpPr>
+          <p:cNvPr id="30" name="Shape 23"/>
+          <p:cNvSpPr/>
+          <p:nvPr/>
+        </p:nvSpPr>
+        <p:spPr>
+          <a:xfrm>
+            <a:off x="6080760" y="2907792"/>
+            <a:ext cx="2651760" cy="1783080"/>
+          </a:xfrm>
+          <a:prstGeom prst="rect">
+            <a:avLst/>
+          </a:prstGeom>
+          <a:solidFill>
+            <a:srgbClr val="161616"/>
+          </a:solidFill>
+          <a:ln w="12700">
+            <a:solidFill>
+              <a:srgbClr val="0D0D0D"/>
+            </a:solidFill>
+            <a:prstDash val="solid"/>
+          </a:ln>
+        </p:spPr>
+      </p:sp>
+      <p:sp>
+        <p:nvSpPr>
+          <p:cNvPr id="31" name="Shape 24"/>
+          <p:cNvSpPr/>
+          <p:nvPr/>
+        </p:nvSpPr>
+        <p:spPr>
+          <a:xfrm>
+            <a:off x="6080760" y="2907792"/>
+            <a:ext cx="45720" cy="1783080"/>
+          </a:xfrm>
+          <a:prstGeom prst="rect">
+            <a:avLst/>
+          </a:prstGeom>
+          <a:solidFill>
+            <a:srgbClr val="0D0D0D"/>
+          </a:solidFill>
+          <a:ln w="12700">
+            <a:solidFill>
+              <a:srgbClr val="0D0D0D"/>
+            </a:solidFill>
+            <a:prstDash val="solid"/>
+          </a:ln>
+        </p:spPr>
+      </p:sp>
+      <p:pic>
+        <p:nvPicPr>
+          <p:cNvPr id="32" name="Image 5" descr="preencoded.png">    </p:cNvPr>
+          <p:cNvPicPr>
+            <a:picLocks noChangeAspect="1"/>
+          </p:cNvPicPr>
+          <p:nvPr/>
+        </p:nvPicPr>
+        <p:blipFill>
+          <a:blip r:embed="rId6"/>
+          <a:stretch>
+            <a:fillRect/>
+          </a:stretch>
+        </p:blipFill>
+        <p:spPr>
+          <a:xfrm>
+            <a:off x="6217920" y="3163824"/>
+            <a:ext cx="1188720" cy="1188720"/>
+          </a:xfrm>
+          <a:prstGeom prst="rect">
+            <a:avLst/>
+          </a:prstGeom>
+        </p:spPr>
+      </p:pic>
+      <p:sp>
+        <p:nvSpPr>
+          <p:cNvPr id="33" name="Text 25"/>
+          <p:cNvSpPr/>
+          <p:nvPr/>
+        </p:nvSpPr>
+        <p:spPr>
+          <a:xfrm>
+            <a:off x="7498080" y="3182112"/>
+            <a:ext cx="1143000" cy="347472"/>
+          </a:xfrm>
+          <a:prstGeom prst="rect">
+            <a:avLst/>
+          </a:prstGeom>
+          <a:noFill/>
+          <a:ln/>
+        </p:spPr>
+        <p:txBody>
+          <a:bodyPr wrap="square" lIns="0" tIns="0" rIns="0" bIns="0" rtlCol="0" anchor="ctr"/>
+          <a:lstStyle/>
+          <a:p>
+            <a:pPr indent="0" marL="0">
+              <a:buNone/>
+            </a:pPr>
+            <a:r>
+              <a:rPr lang="en-US" sz="1200" b="1" dirty="0">
+                <a:solidFill>
+                  <a:srgbClr val="FFFFFF"/>
+                </a:solidFill>
+                <a:latin typeface="Trebuchet MS" pitchFamily="34" charset="0"/>
+                <a:ea typeface="Trebuchet MS" pitchFamily="34" charset="-122"/>
+                <a:cs typeface="Trebuchet MS" pitchFamily="34" charset="-120"/>
+              </a:rPr>
+              <a:t>ETB · Recursos</a:t>
+            </a:r>
+            <a:endParaRPr lang="en-US" sz="1200" dirty="0"/>
+          </a:p>
+        </p:txBody>
+      </p:sp>
+      <p:sp>
+        <p:nvSpPr>
+          <p:cNvPr id="34" name="Text 26"/>
+          <p:cNvSpPr/>
+          <p:nvPr/>
+        </p:nvSpPr>
+        <p:spPr>
+          <a:xfrm>
+            <a:off x="7498080" y="3547872"/>
+            <a:ext cx="1143000" cy="502920"/>
+          </a:xfrm>
+          <a:prstGeom prst="rect">
+            <a:avLst/>
+          </a:prstGeom>
+          <a:noFill/>
+          <a:ln/>
+        </p:spPr>
+        <p:txBody>
+          <a:bodyPr wrap="square" lIns="0" tIns="0" rIns="0" bIns="0" rtlCol="0" anchor="ctr"/>
+          <a:lstStyle/>
+          <a:p>
+            <a:pPr indent="0" marL="0">
+              <a:buNone/>
+            </a:pPr>
+            <a:r>
+              <a:rPr lang="en-US" sz="800" i="1" dirty="0">
+                <a:solidFill>
+                  <a:srgbClr val="00B4D8"/>
+                </a:solidFill>
+                <a:latin typeface="Calibri" pitchFamily="34" charset="0"/>
+                <a:ea typeface="Calibri" pitchFamily="34" charset="-122"/>
+                <a:cs typeface="Calibri" pitchFamily="34" charset="-120"/>
+              </a:rPr>
+              <a:t>etbeducation.github.io/workflow-ia-religion</a:t>
+            </a:r>
+            <a:endParaRPr lang="en-US" sz="800" dirty="0"/>
+          </a:p>
+        </p:txBody>
+      </p:sp>
+      <p:sp>
+        <p:nvSpPr>
+          <p:cNvPr id="35" name="Shape 27"/>
+          <p:cNvSpPr/>
+          <p:nvPr/>
+        </p:nvSpPr>
+        <p:spPr>
+          <a:xfrm>
+            <a:off x="0" y="4773168"/>
+            <a:ext cx="9144000" cy="36576"/>
+          </a:xfrm>
+          <a:prstGeom prst="rect">
+            <a:avLst/>
+          </a:prstGeom>
+          <a:solidFill>
+            <a:srgbClr val="00B4D8"/>
+          </a:solidFill>
+          <a:ln w="12700">
+            <a:solidFill>
+              <a:srgbClr val="00B4D8"/>
+            </a:solidFill>
+            <a:prstDash val="solid"/>
+          </a:ln>
+        </p:spPr>
+      </p:sp>
+      <p:sp>
+        <p:nvSpPr>
+          <p:cNvPr id="36" name="Text 28"/>
+          <p:cNvSpPr/>
+          <p:nvPr/>
+        </p:nvSpPr>
+        <p:spPr>
+          <a:xfrm>
+            <a:off x="457200" y="4846320"/>
+            <a:ext cx="8229600" cy="228600"/>
+          </a:xfrm>
+          <a:prstGeom prst="rect">
+            <a:avLst/>
+          </a:prstGeom>
+          <a:noFill/>
+          <a:ln/>
+        </p:spPr>
+        <p:txBody>
+          <a:bodyPr wrap="square" lIns="0" tIns="0" rIns="0" bIns="0" rtlCol="0" anchor="ctr"/>
+          <a:lstStyle/>
+          <a:p>
+            <a:pPr algn="ctr" indent="0" marL="0">
+              <a:buNone/>
+            </a:pPr>
+            <a:r>
+              <a:rPr lang="en-US" sz="750" dirty="0">
+                <a:solidFill>
+                  <a:srgbClr val="444444"/>
+                </a:solidFill>
+                <a:latin typeface="Calibri" pitchFamily="34" charset="0"/>
+                <a:ea typeface="Calibri" pitchFamily="34" charset="-122"/>
+                <a:cs typeface="Calibri" pitchFamily="34" charset="-120"/>
+              </a:rPr>
+              <a:t>[EdTech Believers] ETB.education · Empowering Education for the Digital Age</a:t>
+            </a:r>
+            <a:endParaRPr lang="en-US" sz="750" dirty="0"/>
+          </a:p>
+        </p:txBody>
+      </p:sp>
+    </p:spTree>
+  </p:cSld>
+  <p:clrMapOvr>
+    <a:masterClrMapping/>
+  </p:clrMapOvr>
+</p:sld>
+</file>
+
+<file path=ppt/slides/slide7.xml><?xml version="1.0" encoding="utf-8"?>
+<p:sld xmlns:a="http://schemas.openxmlformats.org/drawingml/2006/main" xmlns:r="http://schemas.openxmlformats.org/officeDocument/2006/relationships" xmlns:p="http://schemas.openxmlformats.org/presentationml/2006/main">
+  <p:cSld name="Slide 7">
     <p:bg>
       <p:bgPr>
         <a:solidFill>

</xml_diff>

<commit_message>
Update: fix Magisterium URL, remove editorial, 5 QR grid
</commit_message>
<xml_diff>
--- a/ETB-IA-Religion-Video.pptx
+++ b/ETB-IA-Religion-Video.pptx
@@ -985,14 +985,13 @@
             <a:r>
               <a:rPr lang="en-US" dirty="0"/>
               <a:t>NOTAS DEL PRESENTADOR — SLIDE QR · HERRAMIENTAS
-Esta slide se queda en pantalla mientras hacen preguntas o mientras los maestros sacan sus teléfonos.
-Antes de cerrar — aquí tienen acceso directo a todo lo que vimos hoy. Seis códigos QR:
-NotebookLM — gratuito con cuenta de Google. Suban el PDF de sus estándares esta semana.
-Magisterium AI — tiene versión gratuita con límite de consultas. Suficiente para empezar.
-La plataforma editorial de su libro — ya la tienen. Solo que ahora la van a usar diferente: como generador del primer prompt.
-MagicSchool AI — muchos de ustedes ya la conocen. Úsenla con el prompt que construye el workflow.
-CopilotERE — el asistente personalizado para maestros de religión. Tiene los estándares cargados.
-Y el repo de ETB — ahí están el workflow completo, el diagrama, y el prompt template descargable.
+Esta slide se queda en pantalla mientras los maestros sacan sus teléfonos o hacen preguntas.
+Cinco recursos — todos accesibles desde hoy:
+NotebookLM — gratuito con cuenta de Google. Esta semana carguen el PDF de sus estándares y háganle una pregunta.
+Magisterium AI — fuentes acotadas al Magisterio oficial. Tiene versión gratuita para empezar.
+MagicSchool AI — para generar recursos específicos rápido. El mismo prompt del workflow funciona aquí.
+CopilotERE — el asistente construido específicamente para maestros de religión, con los estándares cargados.
+Y el repo de ETB — el workflow completo, el diagrama interactivo, y el prompt template para descargar.
 [Dejar la slide en pantalla · dar tiempo para escanear]</a:t>
             </a:r>
             <a:endParaRPr lang="en-US" dirty="0"/>
@@ -6195,8 +6194,8 @@
         </p:nvSpPr>
         <p:spPr>
           <a:xfrm>
-            <a:off x="457200" y="384048"/>
-            <a:ext cx="8229600" cy="438912"/>
+            <a:off x="457200" y="402336"/>
+            <a:ext cx="8229600" cy="420624"/>
           </a:xfrm>
           <a:prstGeom prst="rect">
             <a:avLst/>
@@ -6235,7 +6234,7 @@
         <p:spPr>
           <a:xfrm>
             <a:off x="411480" y="960120"/>
-            <a:ext cx="2651760" cy="1783080"/>
+            <a:ext cx="2651760" cy="1737360"/>
           </a:xfrm>
           <a:prstGeom prst="rect">
             <a:avLst/>
@@ -6260,7 +6259,7 @@
         <p:spPr>
           <a:xfrm>
             <a:off x="411480" y="960120"/>
-            <a:ext cx="45720" cy="1783080"/>
+            <a:ext cx="45720" cy="1737360"/>
           </a:xfrm>
           <a:prstGeom prst="rect">
             <a:avLst/>
@@ -6293,7 +6292,7 @@
         <p:spPr>
           <a:xfrm>
             <a:off x="548640" y="1216152"/>
-            <a:ext cx="1188720" cy="1188720"/>
+            <a:ext cx="1170432" cy="1170432"/>
           </a:xfrm>
           <a:prstGeom prst="rect">
             <a:avLst/>
@@ -6308,7 +6307,7 @@
         </p:nvSpPr>
         <p:spPr>
           <a:xfrm>
-            <a:off x="1828800" y="1234440"/>
+            <a:off x="1828800" y="1216152"/>
             <a:ext cx="1143000" cy="347472"/>
           </a:xfrm>
           <a:prstGeom prst="rect">
@@ -6325,7 +6324,7 @@
               <a:buNone/>
             </a:pPr>
             <a:r>
-              <a:rPr lang="en-US" sz="1200" b="1" dirty="0">
+              <a:rPr lang="en-US" sz="1150" b="1" dirty="0">
                 <a:solidFill>
                   <a:srgbClr val="FFFFFF"/>
                 </a:solidFill>
@@ -6335,7 +6334,7 @@
               </a:rPr>
               <a:t>NotebookLM</a:t>
             </a:r>
-            <a:endParaRPr lang="en-US" sz="1200" dirty="0"/>
+            <a:endParaRPr lang="en-US" sz="1150" dirty="0"/>
           </a:p>
         </p:txBody>
       </p:sp>
@@ -6348,7 +6347,7 @@
         <p:spPr>
           <a:xfrm>
             <a:off x="1828800" y="1600200"/>
-            <a:ext cx="1143000" cy="502920"/>
+            <a:ext cx="1143000" cy="457200"/>
           </a:xfrm>
           <a:prstGeom prst="rect">
             <a:avLst/>
@@ -6364,7 +6363,7 @@
               <a:buNone/>
             </a:pPr>
             <a:r>
-              <a:rPr lang="en-US" sz="800" i="1" dirty="0">
+              <a:rPr lang="en-US" sz="750" i="1" dirty="0">
                 <a:solidFill>
                   <a:srgbClr val="00B4D8"/>
                 </a:solidFill>
@@ -6374,7 +6373,7 @@
               </a:rPr>
               <a:t>notebooklm.google.com</a:t>
             </a:r>
-            <a:endParaRPr lang="en-US" sz="800" dirty="0"/>
+            <a:endParaRPr lang="en-US" sz="750" dirty="0"/>
           </a:p>
         </p:txBody>
       </p:sp>
@@ -6387,7 +6386,7 @@
         <p:spPr>
           <a:xfrm>
             <a:off x="3246120" y="960120"/>
-            <a:ext cx="2651760" cy="1783080"/>
+            <a:ext cx="2651760" cy="1737360"/>
           </a:xfrm>
           <a:prstGeom prst="rect">
             <a:avLst/>
@@ -6412,7 +6411,7 @@
         <p:spPr>
           <a:xfrm>
             <a:off x="3246120" y="960120"/>
-            <a:ext cx="45720" cy="1783080"/>
+            <a:ext cx="45720" cy="1737360"/>
           </a:xfrm>
           <a:prstGeom prst="rect">
             <a:avLst/>
@@ -6445,7 +6444,7 @@
         <p:spPr>
           <a:xfrm>
             <a:off x="3383280" y="1216152"/>
-            <a:ext cx="1188720" cy="1188720"/>
+            <a:ext cx="1170432" cy="1170432"/>
           </a:xfrm>
           <a:prstGeom prst="rect">
             <a:avLst/>
@@ -6460,7 +6459,7 @@
         </p:nvSpPr>
         <p:spPr>
           <a:xfrm>
-            <a:off x="4663440" y="1234440"/>
+            <a:off x="4663440" y="1216152"/>
             <a:ext cx="1143000" cy="347472"/>
           </a:xfrm>
           <a:prstGeom prst="rect">
@@ -6477,7 +6476,7 @@
               <a:buNone/>
             </a:pPr>
             <a:r>
-              <a:rPr lang="en-US" sz="1200" b="1" dirty="0">
+              <a:rPr lang="en-US" sz="1150" b="1" dirty="0">
                 <a:solidFill>
                   <a:srgbClr val="FFFFFF"/>
                 </a:solidFill>
@@ -6487,7 +6486,7 @@
               </a:rPr>
               <a:t>Magisterium AI</a:t>
             </a:r>
-            <a:endParaRPr lang="en-US" sz="1200" dirty="0"/>
+            <a:endParaRPr lang="en-US" sz="1150" dirty="0"/>
           </a:p>
         </p:txBody>
       </p:sp>
@@ -6500,7 +6499,7 @@
         <p:spPr>
           <a:xfrm>
             <a:off x="4663440" y="1600200"/>
-            <a:ext cx="1143000" cy="502920"/>
+            <a:ext cx="1143000" cy="457200"/>
           </a:xfrm>
           <a:prstGeom prst="rect">
             <a:avLst/>
@@ -6516,7 +6515,7 @@
               <a:buNone/>
             </a:pPr>
             <a:r>
-              <a:rPr lang="en-US" sz="800" i="1" dirty="0">
+              <a:rPr lang="en-US" sz="750" i="1" dirty="0">
                 <a:solidFill>
                   <a:srgbClr val="2DC653"/>
                 </a:solidFill>
@@ -6524,9 +6523,9 @@
                 <a:ea typeface="Calibri" pitchFamily="34" charset="-122"/>
                 <a:cs typeface="Calibri" pitchFamily="34" charset="-120"/>
               </a:rPr>
-              <a:t>magisteriumai.com</a:t>
-            </a:r>
-            <a:endParaRPr lang="en-US" sz="800" dirty="0"/>
+              <a:t>magisterium.com/es</a:t>
+            </a:r>
+            <a:endParaRPr lang="en-US" sz="750" dirty="0"/>
           </a:p>
         </p:txBody>
       </p:sp>
@@ -6539,7 +6538,7 @@
         <p:spPr>
           <a:xfrm>
             <a:off x="6080760" y="960120"/>
-            <a:ext cx="2651760" cy="1783080"/>
+            <a:ext cx="2651760" cy="1737360"/>
           </a:xfrm>
           <a:prstGeom prst="rect">
             <a:avLst/>
@@ -6549,7 +6548,7 @@
           </a:solidFill>
           <a:ln w="12700">
             <a:solidFill>
-              <a:srgbClr val="F4A01C"/>
+              <a:srgbClr val="7B5EA7"/>
             </a:solidFill>
             <a:prstDash val="solid"/>
           </a:ln>
@@ -6564,17 +6563,17 @@
         <p:spPr>
           <a:xfrm>
             <a:off x="6080760" y="960120"/>
-            <a:ext cx="45720" cy="1783080"/>
-          </a:xfrm>
-          <a:prstGeom prst="rect">
-            <a:avLst/>
-          </a:prstGeom>
-          <a:solidFill>
-            <a:srgbClr val="F4A01C"/>
+            <a:ext cx="45720" cy="1737360"/>
+          </a:xfrm>
+          <a:prstGeom prst="rect">
+            <a:avLst/>
+          </a:prstGeom>
+          <a:solidFill>
+            <a:srgbClr val="7B5EA7"/>
           </a:solidFill>
           <a:ln w="12700">
             <a:solidFill>
-              <a:srgbClr val="F4A01C"/>
+              <a:srgbClr val="7B5EA7"/>
             </a:solidFill>
             <a:prstDash val="solid"/>
           </a:ln>
@@ -6597,7 +6596,7 @@
         <p:spPr>
           <a:xfrm>
             <a:off x="6217920" y="1216152"/>
-            <a:ext cx="1188720" cy="1188720"/>
+            <a:ext cx="1170432" cy="1170432"/>
           </a:xfrm>
           <a:prstGeom prst="rect">
             <a:avLst/>
@@ -6612,7 +6611,7 @@
         </p:nvSpPr>
         <p:spPr>
           <a:xfrm>
-            <a:off x="7498080" y="1234440"/>
+            <a:off x="7498080" y="1216152"/>
             <a:ext cx="1143000" cy="347472"/>
           </a:xfrm>
           <a:prstGeom prst="rect">
@@ -6629,7 +6628,7 @@
               <a:buNone/>
             </a:pPr>
             <a:r>
-              <a:rPr lang="en-US" sz="1200" b="1" dirty="0">
+              <a:rPr lang="en-US" sz="1150" b="1" dirty="0">
                 <a:solidFill>
                   <a:srgbClr val="FFFFFF"/>
                 </a:solidFill>
@@ -6637,9 +6636,9 @@
                 <a:ea typeface="Trebuchet MS" pitchFamily="34" charset="-122"/>
                 <a:cs typeface="Trebuchet MS" pitchFamily="34" charset="-120"/>
               </a:rPr>
-              <a:t>Plataforma Editorial</a:t>
-            </a:r>
-            <a:endParaRPr lang="en-US" sz="1200" dirty="0"/>
+              <a:t>MagicSchool AI</a:t>
+            </a:r>
+            <a:endParaRPr lang="en-US" sz="1150" dirty="0"/>
           </a:p>
         </p:txBody>
       </p:sp>
@@ -6652,7 +6651,7 @@
         <p:spPr>
           <a:xfrm>
             <a:off x="7498080" y="1600200"/>
-            <a:ext cx="1143000" cy="502920"/>
+            <a:ext cx="1143000" cy="457200"/>
           </a:xfrm>
           <a:prstGeom prst="rect">
             <a:avLst/>
@@ -6668,17 +6667,17 @@
               <a:buNone/>
             </a:pPr>
             <a:r>
-              <a:rPr lang="en-US" sz="800" i="1" dirty="0">
-                <a:solidFill>
-                  <a:srgbClr val="F4A01C"/>
+              <a:rPr lang="en-US" sz="750" i="1" dirty="0">
+                <a:solidFill>
+                  <a:srgbClr val="7B5EA7"/>
                 </a:solidFill>
                 <a:latin typeface="Calibri" pitchFamily="34" charset="0"/>
                 <a:ea typeface="Calibri" pitchFamily="34" charset="-122"/>
                 <a:cs typeface="Calibri" pitchFamily="34" charset="-120"/>
               </a:rPr>
-              <a:t>edicionessm.com</a:t>
-            </a:r>
-            <a:endParaRPr lang="en-US" sz="800" dirty="0"/>
+              <a:t>magicschool.ai</a:t>
+            </a:r>
+            <a:endParaRPr lang="en-US" sz="750" dirty="0"/>
           </a:p>
         </p:txBody>
       </p:sp>
@@ -6690,8 +6689,8 @@
         </p:nvSpPr>
         <p:spPr>
           <a:xfrm>
-            <a:off x="411480" y="2907792"/>
-            <a:ext cx="2651760" cy="1783080"/>
+            <a:off x="1783080" y="2834640"/>
+            <a:ext cx="2651760" cy="1737360"/>
           </a:xfrm>
           <a:prstGeom prst="rect">
             <a:avLst/>
@@ -6701,7 +6700,7 @@
           </a:solidFill>
           <a:ln w="12700">
             <a:solidFill>
-              <a:srgbClr val="7B5EA7"/>
+              <a:srgbClr val="0096B7"/>
             </a:solidFill>
             <a:prstDash val="solid"/>
           </a:ln>
@@ -6715,18 +6714,18 @@
         </p:nvSpPr>
         <p:spPr>
           <a:xfrm>
-            <a:off x="411480" y="2907792"/>
-            <a:ext cx="45720" cy="1783080"/>
-          </a:xfrm>
-          <a:prstGeom prst="rect">
-            <a:avLst/>
-          </a:prstGeom>
-          <a:solidFill>
-            <a:srgbClr val="7B5EA7"/>
+            <a:off x="1783080" y="2834640"/>
+            <a:ext cx="45720" cy="1737360"/>
+          </a:xfrm>
+          <a:prstGeom prst="rect">
+            <a:avLst/>
+          </a:prstGeom>
+          <a:solidFill>
+            <a:srgbClr val="0096B7"/>
           </a:solidFill>
           <a:ln w="12700">
             <a:solidFill>
-              <a:srgbClr val="7B5EA7"/>
+              <a:srgbClr val="0096B7"/>
             </a:solidFill>
             <a:prstDash val="solid"/>
           </a:ln>
@@ -6748,8 +6747,8 @@
         </p:blipFill>
         <p:spPr>
           <a:xfrm>
-            <a:off x="548640" y="3163824"/>
-            <a:ext cx="1188720" cy="1188720"/>
+            <a:off x="1920240" y="3090672"/>
+            <a:ext cx="1170432" cy="1170432"/>
           </a:xfrm>
           <a:prstGeom prst="rect">
             <a:avLst/>
@@ -6764,7 +6763,7 @@
         </p:nvSpPr>
         <p:spPr>
           <a:xfrm>
-            <a:off x="1828800" y="3182112"/>
+            <a:off x="3200400" y="3090672"/>
             <a:ext cx="1143000" cy="347472"/>
           </a:xfrm>
           <a:prstGeom prst="rect">
@@ -6781,7 +6780,7 @@
               <a:buNone/>
             </a:pPr>
             <a:r>
-              <a:rPr lang="en-US" sz="1200" b="1" dirty="0">
+              <a:rPr lang="en-US" sz="1150" b="1" dirty="0">
                 <a:solidFill>
                   <a:srgbClr val="FFFFFF"/>
                 </a:solidFill>
@@ -6789,9 +6788,9 @@
                 <a:ea typeface="Trebuchet MS" pitchFamily="34" charset="-122"/>
                 <a:cs typeface="Trebuchet MS" pitchFamily="34" charset="-120"/>
               </a:rPr>
-              <a:t>MagicSchool AI</a:t>
-            </a:r>
-            <a:endParaRPr lang="en-US" sz="1200" dirty="0"/>
+              <a:t>CopilotERE</a:t>
+            </a:r>
+            <a:endParaRPr lang="en-US" sz="1150" dirty="0"/>
           </a:p>
         </p:txBody>
       </p:sp>
@@ -6803,8 +6802,8 @@
         </p:nvSpPr>
         <p:spPr>
           <a:xfrm>
-            <a:off x="1828800" y="3547872"/>
-            <a:ext cx="1143000" cy="502920"/>
+            <a:off x="3200400" y="3474720"/>
+            <a:ext cx="1143000" cy="457200"/>
           </a:xfrm>
           <a:prstGeom prst="rect">
             <a:avLst/>
@@ -6820,17 +6819,17 @@
               <a:buNone/>
             </a:pPr>
             <a:r>
-              <a:rPr lang="en-US" sz="800" i="1" dirty="0">
-                <a:solidFill>
-                  <a:srgbClr val="7B5EA7"/>
+              <a:rPr lang="en-US" sz="750" i="1" dirty="0">
+                <a:solidFill>
+                  <a:srgbClr val="0096B7"/>
                 </a:solidFill>
                 <a:latin typeface="Calibri" pitchFamily="34" charset="0"/>
                 <a:ea typeface="Calibri" pitchFamily="34" charset="-122"/>
                 <a:cs typeface="Calibri" pitchFamily="34" charset="-120"/>
               </a:rPr>
-              <a:t>magicschool.ai</a:t>
-            </a:r>
-            <a:endParaRPr lang="en-US" sz="800" dirty="0"/>
+              <a:t>chatgpt.com/g/g-NPtdk5rJ0</a:t>
+            </a:r>
+            <a:endParaRPr lang="en-US" sz="750" dirty="0"/>
           </a:p>
         </p:txBody>
       </p:sp>
@@ -6842,8 +6841,8 @@
         </p:nvSpPr>
         <p:spPr>
           <a:xfrm>
-            <a:off x="3246120" y="2907792"/>
-            <a:ext cx="2651760" cy="1783080"/>
+            <a:off x="4617720" y="2834640"/>
+            <a:ext cx="2651760" cy="1737360"/>
           </a:xfrm>
           <a:prstGeom prst="rect">
             <a:avLst/>
@@ -6853,7 +6852,7 @@
           </a:solidFill>
           <a:ln w="12700">
             <a:solidFill>
-              <a:srgbClr val="0096B7"/>
+              <a:srgbClr val="00B4D8"/>
             </a:solidFill>
             <a:prstDash val="solid"/>
           </a:ln>
@@ -6867,18 +6866,18 @@
         </p:nvSpPr>
         <p:spPr>
           <a:xfrm>
-            <a:off x="3246120" y="2907792"/>
-            <a:ext cx="45720" cy="1783080"/>
-          </a:xfrm>
-          <a:prstGeom prst="rect">
-            <a:avLst/>
-          </a:prstGeom>
-          <a:solidFill>
-            <a:srgbClr val="0096B7"/>
+            <a:off x="4617720" y="2834640"/>
+            <a:ext cx="45720" cy="1737360"/>
+          </a:xfrm>
+          <a:prstGeom prst="rect">
+            <a:avLst/>
+          </a:prstGeom>
+          <a:solidFill>
+            <a:srgbClr val="00B4D8"/>
           </a:solidFill>
           <a:ln w="12700">
             <a:solidFill>
-              <a:srgbClr val="0096B7"/>
+              <a:srgbClr val="00B4D8"/>
             </a:solidFill>
             <a:prstDash val="solid"/>
           </a:ln>
@@ -6900,8 +6899,8 @@
         </p:blipFill>
         <p:spPr>
           <a:xfrm>
-            <a:off x="3383280" y="3163824"/>
-            <a:ext cx="1188720" cy="1188720"/>
+            <a:off x="4754880" y="3090672"/>
+            <a:ext cx="1170432" cy="1170432"/>
           </a:xfrm>
           <a:prstGeom prst="rect">
             <a:avLst/>
@@ -6916,7 +6915,7 @@
         </p:nvSpPr>
         <p:spPr>
           <a:xfrm>
-            <a:off x="4663440" y="3182112"/>
+            <a:off x="6035040" y="3090672"/>
             <a:ext cx="1143000" cy="347472"/>
           </a:xfrm>
           <a:prstGeom prst="rect">
@@ -6933,7 +6932,7 @@
               <a:buNone/>
             </a:pPr>
             <a:r>
-              <a:rPr lang="en-US" sz="1200" b="1" dirty="0">
+              <a:rPr lang="en-US" sz="1150" b="1" dirty="0">
                 <a:solidFill>
                   <a:srgbClr val="FFFFFF"/>
                 </a:solidFill>
@@ -6941,9 +6940,9 @@
                 <a:ea typeface="Trebuchet MS" pitchFamily="34" charset="-122"/>
                 <a:cs typeface="Trebuchet MS" pitchFamily="34" charset="-120"/>
               </a:rPr>
-              <a:t>CopilotERE</a:t>
-            </a:r>
-            <a:endParaRPr lang="en-US" sz="1200" dirty="0"/>
+              <a:t>ETB · Recursos</a:t>
+            </a:r>
+            <a:endParaRPr lang="en-US" sz="1150" dirty="0"/>
           </a:p>
         </p:txBody>
       </p:sp>
@@ -6955,8 +6954,8 @@
         </p:nvSpPr>
         <p:spPr>
           <a:xfrm>
-            <a:off x="4663440" y="3547872"/>
-            <a:ext cx="1143000" cy="502920"/>
+            <a:off x="6035040" y="3474720"/>
+            <a:ext cx="1143000" cy="457200"/>
           </a:xfrm>
           <a:prstGeom prst="rect">
             <a:avLst/>
@@ -6972,175 +6971,23 @@
               <a:buNone/>
             </a:pPr>
             <a:r>
-              <a:rPr lang="en-US" sz="800" i="1" dirty="0">
-                <a:solidFill>
-                  <a:srgbClr val="0096B7"/>
+              <a:rPr lang="en-US" sz="750" i="1" dirty="0">
+                <a:solidFill>
+                  <a:srgbClr val="00B4D8"/>
                 </a:solidFill>
                 <a:latin typeface="Calibri" pitchFamily="34" charset="0"/>
                 <a:ea typeface="Calibri" pitchFamily="34" charset="-122"/>
                 <a:cs typeface="Calibri" pitchFamily="34" charset="-120"/>
               </a:rPr>
-              <a:t>chatgpt.com/g/g-NPtdk5rJ0</a:t>
-            </a:r>
-            <a:endParaRPr lang="en-US" sz="800" dirty="0"/>
+              <a:t>etbeducation.github.io/workflow-ia-religion</a:t>
+            </a:r>
+            <a:endParaRPr lang="en-US" sz="750" dirty="0"/>
           </a:p>
         </p:txBody>
       </p:sp>
       <p:sp>
         <p:nvSpPr>
           <p:cNvPr id="30" name="Shape 23"/>
-          <p:cNvSpPr/>
-          <p:nvPr/>
-        </p:nvSpPr>
-        <p:spPr>
-          <a:xfrm>
-            <a:off x="6080760" y="2907792"/>
-            <a:ext cx="2651760" cy="1783080"/>
-          </a:xfrm>
-          <a:prstGeom prst="rect">
-            <a:avLst/>
-          </a:prstGeom>
-          <a:solidFill>
-            <a:srgbClr val="161616"/>
-          </a:solidFill>
-          <a:ln w="12700">
-            <a:solidFill>
-              <a:srgbClr val="0D0D0D"/>
-            </a:solidFill>
-            <a:prstDash val="solid"/>
-          </a:ln>
-        </p:spPr>
-      </p:sp>
-      <p:sp>
-        <p:nvSpPr>
-          <p:cNvPr id="31" name="Shape 24"/>
-          <p:cNvSpPr/>
-          <p:nvPr/>
-        </p:nvSpPr>
-        <p:spPr>
-          <a:xfrm>
-            <a:off x="6080760" y="2907792"/>
-            <a:ext cx="45720" cy="1783080"/>
-          </a:xfrm>
-          <a:prstGeom prst="rect">
-            <a:avLst/>
-          </a:prstGeom>
-          <a:solidFill>
-            <a:srgbClr val="0D0D0D"/>
-          </a:solidFill>
-          <a:ln w="12700">
-            <a:solidFill>
-              <a:srgbClr val="0D0D0D"/>
-            </a:solidFill>
-            <a:prstDash val="solid"/>
-          </a:ln>
-        </p:spPr>
-      </p:sp>
-      <p:pic>
-        <p:nvPicPr>
-          <p:cNvPr id="32" name="Image 5" descr="preencoded.png">    </p:cNvPr>
-          <p:cNvPicPr>
-            <a:picLocks noChangeAspect="1"/>
-          </p:cNvPicPr>
-          <p:nvPr/>
-        </p:nvPicPr>
-        <p:blipFill>
-          <a:blip r:embed="rId6"/>
-          <a:stretch>
-            <a:fillRect/>
-          </a:stretch>
-        </p:blipFill>
-        <p:spPr>
-          <a:xfrm>
-            <a:off x="6217920" y="3163824"/>
-            <a:ext cx="1188720" cy="1188720"/>
-          </a:xfrm>
-          <a:prstGeom prst="rect">
-            <a:avLst/>
-          </a:prstGeom>
-        </p:spPr>
-      </p:pic>
-      <p:sp>
-        <p:nvSpPr>
-          <p:cNvPr id="33" name="Text 25"/>
-          <p:cNvSpPr/>
-          <p:nvPr/>
-        </p:nvSpPr>
-        <p:spPr>
-          <a:xfrm>
-            <a:off x="7498080" y="3182112"/>
-            <a:ext cx="1143000" cy="347472"/>
-          </a:xfrm>
-          <a:prstGeom prst="rect">
-            <a:avLst/>
-          </a:prstGeom>
-          <a:noFill/>
-          <a:ln/>
-        </p:spPr>
-        <p:txBody>
-          <a:bodyPr wrap="square" lIns="0" tIns="0" rIns="0" bIns="0" rtlCol="0" anchor="ctr"/>
-          <a:lstStyle/>
-          <a:p>
-            <a:pPr indent="0" marL="0">
-              <a:buNone/>
-            </a:pPr>
-            <a:r>
-              <a:rPr lang="en-US" sz="1200" b="1" dirty="0">
-                <a:solidFill>
-                  <a:srgbClr val="FFFFFF"/>
-                </a:solidFill>
-                <a:latin typeface="Trebuchet MS" pitchFamily="34" charset="0"/>
-                <a:ea typeface="Trebuchet MS" pitchFamily="34" charset="-122"/>
-                <a:cs typeface="Trebuchet MS" pitchFamily="34" charset="-120"/>
-              </a:rPr>
-              <a:t>ETB · Recursos</a:t>
-            </a:r>
-            <a:endParaRPr lang="en-US" sz="1200" dirty="0"/>
-          </a:p>
-        </p:txBody>
-      </p:sp>
-      <p:sp>
-        <p:nvSpPr>
-          <p:cNvPr id="34" name="Text 26"/>
-          <p:cNvSpPr/>
-          <p:nvPr/>
-        </p:nvSpPr>
-        <p:spPr>
-          <a:xfrm>
-            <a:off x="7498080" y="3547872"/>
-            <a:ext cx="1143000" cy="502920"/>
-          </a:xfrm>
-          <a:prstGeom prst="rect">
-            <a:avLst/>
-          </a:prstGeom>
-          <a:noFill/>
-          <a:ln/>
-        </p:spPr>
-        <p:txBody>
-          <a:bodyPr wrap="square" lIns="0" tIns="0" rIns="0" bIns="0" rtlCol="0" anchor="ctr"/>
-          <a:lstStyle/>
-          <a:p>
-            <a:pPr indent="0" marL="0">
-              <a:buNone/>
-            </a:pPr>
-            <a:r>
-              <a:rPr lang="en-US" sz="800" i="1" dirty="0">
-                <a:solidFill>
-                  <a:srgbClr val="00B4D8"/>
-                </a:solidFill>
-                <a:latin typeface="Calibri" pitchFamily="34" charset="0"/>
-                <a:ea typeface="Calibri" pitchFamily="34" charset="-122"/>
-                <a:cs typeface="Calibri" pitchFamily="34" charset="-120"/>
-              </a:rPr>
-              <a:t>etbeducation.github.io/workflow-ia-religion</a:t>
-            </a:r>
-            <a:endParaRPr lang="en-US" sz="800" dirty="0"/>
-          </a:p>
-        </p:txBody>
-      </p:sp>
-      <p:sp>
-        <p:nvSpPr>
-          <p:cNvPr id="35" name="Shape 27"/>
           <p:cNvSpPr/>
           <p:nvPr/>
         </p:nvSpPr>
@@ -7165,7 +7012,7 @@
       </p:sp>
       <p:sp>
         <p:nvSpPr>
-          <p:cNvPr id="36" name="Text 28"/>
+          <p:cNvPr id="31" name="Text 24"/>
           <p:cNvSpPr/>
           <p:nvPr/>
         </p:nvSpPr>

</xml_diff>